<commit_message>
Refresh review deck package
</commit_message>
<xml_diff>
--- a/outputs/submission_pack/deliverables/scievo_labtrace_overview.pptx
+++ b/outputs/submission_pack/deliverables/scievo_labtrace_overview.pptx
@@ -1521,6 +1521,7 @@
           <a:bodyPr xmlns:a="http://schemas.openxmlformats.org/drawingml/2006/main" wrap="square" lIns="76200" tIns="38100" rIns="76200" bIns="38100" anchor="ctr"/>
           <a:lstStyle xmlns:a="http://schemas.openxmlformats.org/drawingml/2006/main"/>
           <a:p xmlns:a="http://schemas.openxmlformats.org/drawingml/2006/main">
+            <a:pPr/>
             <a:r>
               <a:t>MinerU · Sci-Evo</a:t>
             </a:r>
@@ -1555,6 +1556,7 @@
           <a:bodyPr xmlns:a="http://schemas.openxmlformats.org/drawingml/2006/main" wrap="square" lIns="76200" tIns="38100" rIns="76200" bIns="38100" anchor="ctr"/>
           <a:lstStyle xmlns:a="http://schemas.openxmlformats.org/drawingml/2006/main"/>
           <a:p xmlns:a="http://schemas.openxmlformats.org/drawingml/2006/main">
+            <a:pPr/>
             <a:r>
               <a:t>Sci-Evo-LabTrace</a:t>
             </a:r>
@@ -1589,8 +1591,9 @@
           <a:bodyPr xmlns:a="http://schemas.openxmlformats.org/drawingml/2006/main" wrap="square" lIns="76200" tIns="38100" rIns="76200" bIns="38100" anchor="ctr"/>
           <a:lstStyle xmlns:a="http://schemas.openxmlformats.org/drawingml/2006/main"/>
           <a:p xmlns:a="http://schemas.openxmlformats.org/drawingml/2006/main">
-            <a:r>
-              <a:t>面向 AI4S 科学智能体的科研演化证据数据集</a:t>
+            <a:pPr/>
+            <a:r>
+              <a:t>从论文 PDF 到可训练科研轨迹的数据集</a:t>
             </a:r>
           </a:p>
         </p:txBody>
@@ -1623,8 +1626,9 @@
           <a:bodyPr xmlns:a="http://schemas.openxmlformats.org/drawingml/2006/main" wrap="square" lIns="0" tIns="57150" rIns="76200" bIns="57150" anchor="ctr"/>
           <a:lstStyle xmlns:a="http://schemas.openxmlformats.org/drawingml/2006/main"/>
           <a:p xmlns:a="http://schemas.openxmlformats.org/drawingml/2006/main">
-            <a:r>
-              <a:t>把论文 PDF、MinerU 解析结果和人工证据链整合成可训练、可评测、可追溯的 Sci-Evo gold case。</a:t>
+            <a:pPr/>
+            <a:r>
+              <a:t>一句话：用 MinerU 把论文拆成可追溯证据，再整理成科学智能体能学习和评测的科研过程。</a:t>
             </a:r>
           </a:p>
         </p:txBody>
@@ -1721,6 +1725,7 @@
           <a:bodyPr xmlns:a="http://schemas.openxmlformats.org/drawingml/2006/main" wrap="square" lIns="0" tIns="0" rIns="0" bIns="0" anchor="ctr"/>
           <a:lstStyle xmlns:a="http://schemas.openxmlformats.org/drawingml/2006/main"/>
           <a:p xmlns:a="http://schemas.openxmlformats.org/drawingml/2006/main">
+            <a:pPr/>
             <a:r>
               <a:t>3</a:t>
             </a:r>
@@ -1755,6 +1760,7 @@
           <a:bodyPr xmlns:a="http://schemas.openxmlformats.org/drawingml/2006/main" wrap="square" lIns="0" tIns="0" rIns="0" bIns="0" anchor="ctr"/>
           <a:lstStyle xmlns:a="http://schemas.openxmlformats.org/drawingml/2006/main"/>
           <a:p xmlns:a="http://schemas.openxmlformats.org/drawingml/2006/main">
+            <a:pPr/>
             <a:r>
               <a:t>Gold case</a:t>
             </a:r>
@@ -1821,6 +1827,7 @@
           <a:bodyPr xmlns:a="http://schemas.openxmlformats.org/drawingml/2006/main" wrap="square" lIns="0" tIns="0" rIns="0" bIns="0" anchor="ctr"/>
           <a:lstStyle xmlns:a="http://schemas.openxmlformats.org/drawingml/2006/main"/>
           <a:p xmlns:a="http://schemas.openxmlformats.org/drawingml/2006/main">
+            <a:pPr/>
             <a:r>
               <a:t>17</a:t>
             </a:r>
@@ -1855,6 +1862,7 @@
           <a:bodyPr xmlns:a="http://schemas.openxmlformats.org/drawingml/2006/main" wrap="square" lIns="0" tIns="0" rIns="0" bIns="0" anchor="ctr"/>
           <a:lstStyle xmlns:a="http://schemas.openxmlformats.org/drawingml/2006/main"/>
           <a:p xmlns:a="http://schemas.openxmlformats.org/drawingml/2006/main">
+            <a:pPr/>
             <a:r>
               <a:t>轨迹步骤</a:t>
             </a:r>
@@ -1921,6 +1929,7 @@
           <a:bodyPr xmlns:a="http://schemas.openxmlformats.org/drawingml/2006/main" wrap="square" lIns="0" tIns="0" rIns="0" bIns="0" anchor="ctr"/>
           <a:lstStyle xmlns:a="http://schemas.openxmlformats.org/drawingml/2006/main"/>
           <a:p xmlns:a="http://schemas.openxmlformats.org/drawingml/2006/main">
+            <a:pPr/>
             <a:r>
               <a:t>37</a:t>
             </a:r>
@@ -1955,6 +1964,7 @@
           <a:bodyPr xmlns:a="http://schemas.openxmlformats.org/drawingml/2006/main" wrap="square" lIns="0" tIns="0" rIns="0" bIns="0" anchor="ctr"/>
           <a:lstStyle xmlns:a="http://schemas.openxmlformats.org/drawingml/2006/main"/>
           <a:p xmlns:a="http://schemas.openxmlformats.org/drawingml/2006/main">
+            <a:pPr/>
             <a:r>
               <a:t>评测任务</a:t>
             </a:r>
@@ -2021,6 +2031,7 @@
           <a:bodyPr xmlns:a="http://schemas.openxmlformats.org/drawingml/2006/main" wrap="square" lIns="0" tIns="0" rIns="0" bIns="0" anchor="ctr"/>
           <a:lstStyle xmlns:a="http://schemas.openxmlformats.org/drawingml/2006/main"/>
           <a:p xmlns:a="http://schemas.openxmlformats.org/drawingml/2006/main">
+            <a:pPr/>
             <a:r>
               <a:t>25</a:t>
             </a:r>
@@ -2055,6 +2066,7 @@
           <a:bodyPr xmlns:a="http://schemas.openxmlformats.org/drawingml/2006/main" wrap="square" lIns="0" tIns="0" rIns="0" bIns="0" anchor="ctr"/>
           <a:lstStyle xmlns:a="http://schemas.openxmlformats.org/drawingml/2006/main"/>
           <a:p xmlns:a="http://schemas.openxmlformats.org/drawingml/2006/main">
+            <a:pPr/>
             <a:r>
               <a:t>OA 候选</a:t>
             </a:r>
@@ -2121,8 +2133,14 @@
           <a:bodyPr xmlns:a="http://schemas.openxmlformats.org/drawingml/2006/main" wrap="square" lIns="76200" tIns="38100" rIns="76200" bIns="38100" anchor="ctr"/>
           <a:lstStyle xmlns:a="http://schemas.openxmlformats.org/drawingml/2006/main"/>
           <a:p xmlns:a="http://schemas.openxmlformats.org/drawingml/2006/main">
-            <a:r>
-              <a:t>不是“论文摘要”</a:t>
+            <a:pPr/>
+            <a:r>
+              <a:rPr>
+                <a:solidFill>
+                  <a:srgbClr val="F8FAFC"/>
+                </a:solidFill>
+              </a:rPr>
+              <a:t>一条主线</a:t>
             </a:r>
           </a:p>
         </p:txBody>
@@ -2155,8 +2173,14 @@
           <a:bodyPr xmlns:a="http://schemas.openxmlformats.org/drawingml/2006/main" wrap="square" lIns="0" tIns="0" rIns="0" bIns="0" anchor="ctr"/>
           <a:lstStyle xmlns:a="http://schemas.openxmlformats.org/drawingml/2006/main"/>
           <a:p xmlns:a="http://schemas.openxmlformats.org/drawingml/2006/main">
-            <a:r>
-              <a:t>而是把真实科研中的目标设定、计算设计、湿实验、失败修正和最终验证整理成可学习的轨迹。</a:t>
+            <a:pPr/>
+            <a:r>
+              <a:rPr>
+                <a:solidFill>
+                  <a:srgbClr val="E5E7EB"/>
+                </a:solidFill>
+              </a:rPr>
+              <a:t>论文不是终点；可复核的过程轨迹才是训练科学智能体的资产。</a:t>
             </a:r>
           </a:p>
         </p:txBody>
@@ -2189,7 +2213,13 @@
           <a:bodyPr xmlns:a="http://schemas.openxmlformats.org/drawingml/2006/main" wrap="square" lIns="76200" tIns="38100" rIns="76200" bIns="38100" anchor="ctr"/>
           <a:lstStyle xmlns:a="http://schemas.openxmlformats.org/drawingml/2006/main"/>
           <a:p xmlns:a="http://schemas.openxmlformats.org/drawingml/2006/main">
-            <a:r>
+            <a:pPr/>
+            <a:r>
+              <a:rPr>
+                <a:solidFill>
+                  <a:srgbClr val="C7D2FE"/>
+                </a:solidFill>
+              </a:rPr>
               <a:t>核心差异</a:t>
             </a:r>
           </a:p>
@@ -2223,8 +2253,14 @@
           <a:bodyPr xmlns:a="http://schemas.openxmlformats.org/drawingml/2006/main" wrap="square" lIns="0" tIns="0" rIns="0" bIns="0" anchor="ctr"/>
           <a:lstStyle xmlns:a="http://schemas.openxmlformats.org/drawingml/2006/main"/>
           <a:p xmlns:a="http://schemas.openxmlformats.org/drawingml/2006/main">
-            <a:r>
-              <a:t>论文证据链 + MinerU 块级定位 + 结构化 schema + 自动评测任务</a:t>
+            <a:pPr/>
+            <a:r>
+              <a:rPr>
+                <a:solidFill>
+                  <a:srgbClr val="F8FAFC"/>
+                </a:solidFill>
+              </a:rPr>
+              <a:t>证据先行 → 轨迹抽取 → 评测生成 → 质量闭环</a:t>
             </a:r>
           </a:p>
         </p:txBody>
@@ -2257,6 +2293,7 @@
           <a:bodyPr xmlns:a="http://schemas.openxmlformats.org/drawingml/2006/main" wrap="square" lIns="76200" tIns="38100" rIns="76200" bIns="38100" anchor="ctr"/>
           <a:lstStyle xmlns:a="http://schemas.openxmlformats.org/drawingml/2006/main"/>
           <a:p xmlns:a="http://schemas.openxmlformats.org/drawingml/2006/main">
+            <a:pPr/>
             <a:r>
               <a:t>Sci-Evo · LabTrace</a:t>
             </a:r>
@@ -2291,6 +2328,7 @@
           <a:bodyPr xmlns:a="http://schemas.openxmlformats.org/drawingml/2006/main" wrap="square" lIns="76200" tIns="38100" rIns="76200" bIns="38100" anchor="ctr"/>
           <a:lstStyle xmlns:a="http://schemas.openxmlformats.org/drawingml/2006/main"/>
           <a:p xmlns:a="http://schemas.openxmlformats.org/drawingml/2006/main">
+            <a:pPr/>
             <a:r>
               <a:t>01</a:t>
             </a:r>
@@ -2418,7 +2456,13 @@
           <a:bodyPr xmlns:a="http://schemas.openxmlformats.org/drawingml/2006/main" wrap="square" lIns="76200" tIns="38100" rIns="76200" bIns="38100" anchor="ctr"/>
           <a:lstStyle xmlns:a="http://schemas.openxmlformats.org/drawingml/2006/main"/>
           <a:p xmlns:a="http://schemas.openxmlformats.org/drawingml/2006/main">
-            <a:r>
+            <a:pPr/>
+            <a:r>
+              <a:rPr>
+                <a:solidFill>
+                  <a:srgbClr val="F8FAFC"/>
+                </a:solidFill>
+              </a:rPr>
               <a:t>后续增强</a:t>
             </a:r>
           </a:p>
@@ -2452,8 +2496,14 @@
           <a:bodyPr xmlns:a="http://schemas.openxmlformats.org/drawingml/2006/main" wrap="square" lIns="0" tIns="0" rIns="76200" bIns="0" anchor="ctr"/>
           <a:lstStyle xmlns:a="http://schemas.openxmlformats.org/drawingml/2006/main"/>
           <a:p xmlns:a="http://schemas.openxmlformats.org/drawingml/2006/main">
-            <a:r>
-              <a:t>当前版本已具备完整评审材料，后续增强应集中在规模、MinerU 覆盖和许可清晰度。</a:t>
+            <a:pPr/>
+            <a:r>
+              <a:rPr>
+                <a:solidFill>
+                  <a:srgbClr val="E5E7EB"/>
+                </a:solidFill>
+              </a:rPr>
+              <a:t>基础版本已经完整；后续增强集中在规模、MinerU 覆盖和许可清晰度。</a:t>
             </a:r>
           </a:p>
         </p:txBody>
@@ -2486,7 +2536,13 @@
           <a:bodyPr xmlns:a="http://schemas.openxmlformats.org/drawingml/2006/main" wrap="square" lIns="76200" tIns="38100" rIns="76200" bIns="38100" anchor="ctr"/>
           <a:lstStyle xmlns:a="http://schemas.openxmlformats.org/drawingml/2006/main"/>
           <a:p xmlns:a="http://schemas.openxmlformats.org/drawingml/2006/main">
-            <a:r>
+            <a:pPr/>
+            <a:r>
+              <a:rPr>
+                <a:solidFill>
+                  <a:srgbClr val="CBD5E1"/>
+                </a:solidFill>
+              </a:rPr>
               <a:t>Sci-Evo · LabTrace</a:t>
             </a:r>
           </a:p>
@@ -2520,7 +2576,13 @@
           <a:bodyPr xmlns:a="http://schemas.openxmlformats.org/drawingml/2006/main" wrap="square" lIns="76200" tIns="38100" rIns="76200" bIns="38100" anchor="ctr"/>
           <a:lstStyle xmlns:a="http://schemas.openxmlformats.org/drawingml/2006/main"/>
           <a:p xmlns:a="http://schemas.openxmlformats.org/drawingml/2006/main">
-            <a:r>
+            <a:pPr/>
+            <a:r>
+              <a:rPr>
+                <a:solidFill>
+                  <a:srgbClr val="CBD5E1"/>
+                </a:solidFill>
+              </a:rPr>
               <a:t>10</a:t>
             </a:r>
           </a:p>
@@ -2586,7 +2648,13 @@
           <a:bodyPr xmlns:a="http://schemas.openxmlformats.org/drawingml/2006/main" wrap="square" lIns="76200" tIns="38100" rIns="76200" bIns="38100" anchor="ctr"/>
           <a:lstStyle xmlns:a="http://schemas.openxmlformats.org/drawingml/2006/main"/>
           <a:p xmlns:a="http://schemas.openxmlformats.org/drawingml/2006/main">
-            <a:r>
+            <a:pPr/>
+            <a:r>
+              <a:rPr>
+                <a:solidFill>
+                  <a:srgbClr val="C7D2FE"/>
+                </a:solidFill>
+              </a:rPr>
               <a:t>P0</a:t>
             </a:r>
           </a:p>
@@ -2620,7 +2688,13 @@
           <a:bodyPr xmlns:a="http://schemas.openxmlformats.org/drawingml/2006/main" wrap="square" lIns="76200" tIns="38100" rIns="76200" bIns="38100" anchor="ctr"/>
           <a:lstStyle xmlns:a="http://schemas.openxmlformats.org/drawingml/2006/main"/>
           <a:p xmlns:a="http://schemas.openxmlformats.org/drawingml/2006/main">
-            <a:r>
+            <a:pPr/>
+            <a:r>
+              <a:rPr>
+                <a:solidFill>
+                  <a:srgbClr val="F8FAFC"/>
+                </a:solidFill>
+              </a:rPr>
               <a:t>完整基础版本</a:t>
             </a:r>
           </a:p>
@@ -2654,8 +2728,14 @@
           <a:bodyPr xmlns:a="http://schemas.openxmlformats.org/drawingml/2006/main" wrap="square" lIns="0" tIns="57150" rIns="76200" bIns="57150" anchor="ctr"/>
           <a:lstStyle xmlns:a="http://schemas.openxmlformats.org/drawingml/2006/main"/>
           <a:p xmlns:a="http://schemas.openxmlformats.org/drawingml/2006/main">
-            <a:r>
-              <a:t>当前已完成；PPT、数据、报告与校验链齐全。</a:t>
+            <a:pPr/>
+            <a:r>
+              <a:rPr>
+                <a:solidFill>
+                  <a:srgbClr val="CBD5E1"/>
+                </a:solidFill>
+              </a:rPr>
+              <a:t>当前已完成；数据、报告、PPT 与校验链齐全。</a:t>
             </a:r>
           </a:p>
         </p:txBody>
@@ -2720,7 +2800,13 @@
           <a:bodyPr xmlns:a="http://schemas.openxmlformats.org/drawingml/2006/main" wrap="square" lIns="76200" tIns="38100" rIns="76200" bIns="38100" anchor="ctr"/>
           <a:lstStyle xmlns:a="http://schemas.openxmlformats.org/drawingml/2006/main"/>
           <a:p xmlns:a="http://schemas.openxmlformats.org/drawingml/2006/main">
-            <a:r>
+            <a:pPr/>
+            <a:r>
+              <a:rPr>
+                <a:solidFill>
+                  <a:srgbClr val="C7D2FE"/>
+                </a:solidFill>
+              </a:rPr>
               <a:t>P1</a:t>
             </a:r>
           </a:p>
@@ -2754,7 +2840,13 @@
           <a:bodyPr xmlns:a="http://schemas.openxmlformats.org/drawingml/2006/main" wrap="square" lIns="76200" tIns="38100" rIns="76200" bIns="38100" anchor="ctr"/>
           <a:lstStyle xmlns:a="http://schemas.openxmlformats.org/drawingml/2006/main"/>
           <a:p xmlns:a="http://schemas.openxmlformats.org/drawingml/2006/main">
-            <a:r>
+            <a:pPr/>
+            <a:r>
+              <a:rPr>
+                <a:solidFill>
+                  <a:srgbClr val="F8FAFC"/>
+                </a:solidFill>
+              </a:rPr>
               <a:t>扩展更多 OA case</a:t>
             </a:r>
           </a:p>
@@ -2788,7 +2880,13 @@
           <a:bodyPr xmlns:a="http://schemas.openxmlformats.org/drawingml/2006/main" wrap="square" lIns="0" tIns="57150" rIns="76200" bIns="57150" anchor="ctr"/>
           <a:lstStyle xmlns:a="http://schemas.openxmlformats.org/drawingml/2006/main"/>
           <a:p xmlns:a="http://schemas.openxmlformats.org/drawingml/2006/main">
-            <a:r>
+            <a:pPr/>
+            <a:r>
+              <a:rPr>
+                <a:solidFill>
+                  <a:srgbClr val="CBD5E1"/>
+                </a:solidFill>
+              </a:rPr>
               <a:t>优先处理 14 条 permitted_for_local_processing 候选。</a:t>
             </a:r>
           </a:p>
@@ -2854,7 +2952,13 @@
           <a:bodyPr xmlns:a="http://schemas.openxmlformats.org/drawingml/2006/main" wrap="square" lIns="76200" tIns="38100" rIns="76200" bIns="38100" anchor="ctr"/>
           <a:lstStyle xmlns:a="http://schemas.openxmlformats.org/drawingml/2006/main"/>
           <a:p xmlns:a="http://schemas.openxmlformats.org/drawingml/2006/main">
-            <a:r>
+            <a:pPr/>
+            <a:r>
+              <a:rPr>
+                <a:solidFill>
+                  <a:srgbClr val="FBBF24"/>
+                </a:solidFill>
+              </a:rPr>
               <a:t>P2</a:t>
             </a:r>
           </a:p>
@@ -2888,7 +2992,13 @@
           <a:bodyPr xmlns:a="http://schemas.openxmlformats.org/drawingml/2006/main" wrap="square" lIns="76200" tIns="38100" rIns="76200" bIns="38100" anchor="ctr"/>
           <a:lstStyle xmlns:a="http://schemas.openxmlformats.org/drawingml/2006/main"/>
           <a:p xmlns:a="http://schemas.openxmlformats.org/drawingml/2006/main">
-            <a:r>
+            <a:pPr/>
+            <a:r>
+              <a:rPr>
+                <a:solidFill>
+                  <a:srgbClr val="F8FAFC"/>
+                </a:solidFill>
+              </a:rPr>
               <a:t>补齐 MinerU 产物</a:t>
             </a:r>
           </a:p>
@@ -2922,7 +3032,13 @@
           <a:bodyPr xmlns:a="http://schemas.openxmlformats.org/drawingml/2006/main" wrap="square" lIns="0" tIns="57150" rIns="76200" bIns="57150" anchor="ctr"/>
           <a:lstStyle xmlns:a="http://schemas.openxmlformats.org/drawingml/2006/main"/>
           <a:p xmlns:a="http://schemas.openxmlformats.org/drawingml/2006/main">
-            <a:r>
+            <a:pPr/>
+            <a:r>
+              <a:rPr>
+                <a:solidFill>
+                  <a:srgbClr val="CBD5E1"/>
+                </a:solidFill>
+              </a:rPr>
               <a:t>为新增开放论文补本地解析和块级证据绑定。</a:t>
             </a:r>
           </a:p>
@@ -2988,7 +3104,13 @@
           <a:bodyPr xmlns:a="http://schemas.openxmlformats.org/drawingml/2006/main" wrap="square" lIns="76200" tIns="38100" rIns="76200" bIns="38100" anchor="ctr"/>
           <a:lstStyle xmlns:a="http://schemas.openxmlformats.org/drawingml/2006/main"/>
           <a:p xmlns:a="http://schemas.openxmlformats.org/drawingml/2006/main">
-            <a:r>
+            <a:pPr/>
+            <a:r>
+              <a:rPr>
+                <a:solidFill>
+                  <a:srgbClr val="FCA5A5"/>
+                </a:solidFill>
+              </a:rPr>
               <a:t>P3</a:t>
             </a:r>
           </a:p>
@@ -3022,7 +3144,13 @@
           <a:bodyPr xmlns:a="http://schemas.openxmlformats.org/drawingml/2006/main" wrap="square" lIns="76200" tIns="38100" rIns="76200" bIns="38100" anchor="ctr"/>
           <a:lstStyle xmlns:a="http://schemas.openxmlformats.org/drawingml/2006/main"/>
           <a:p xmlns:a="http://schemas.openxmlformats.org/drawingml/2006/main">
-            <a:r>
+            <a:pPr/>
+            <a:r>
+              <a:rPr>
+                <a:solidFill>
+                  <a:srgbClr val="F8FAFC"/>
+                </a:solidFill>
+              </a:rPr>
               <a:t>公开版合规</a:t>
             </a:r>
           </a:p>
@@ -3056,7 +3184,13 @@
           <a:bodyPr xmlns:a="http://schemas.openxmlformats.org/drawingml/2006/main" wrap="square" lIns="0" tIns="57150" rIns="76200" bIns="57150" anchor="ctr"/>
           <a:lstStyle xmlns:a="http://schemas.openxmlformats.org/drawingml/2006/main"/>
           <a:p xmlns:a="http://schemas.openxmlformats.org/drawingml/2006/main">
-            <a:r>
+            <a:pPr/>
+            <a:r>
+              <a:rPr>
+                <a:solidFill>
+                  <a:srgbClr val="CBD5E1"/>
+                </a:solidFill>
+              </a:rPr>
               <a:t>逐条确认全文、图片和解析产物的许可边界。</a:t>
             </a:r>
           </a:p>
@@ -3122,7 +3256,13 @@
           <a:bodyPr xmlns:a="http://schemas.openxmlformats.org/drawingml/2006/main" wrap="square" lIns="76200" tIns="38100" rIns="76200" bIns="38100" anchor="ctr"/>
           <a:lstStyle xmlns:a="http://schemas.openxmlformats.org/drawingml/2006/main"/>
           <a:p xmlns:a="http://schemas.openxmlformats.org/drawingml/2006/main">
-            <a:r>
+            <a:pPr/>
+            <a:r>
+              <a:rPr>
+                <a:solidFill>
+                  <a:srgbClr val="F8FAFC"/>
+                </a:solidFill>
+              </a:rPr>
               <a:t>总结：MinerU 负责把论文变成可信结构化证据，Sci-Evo-LabTrace 负责把证据组织成可训练、可评测、可复核的科研演化数据。</a:t>
             </a:r>
           </a:p>
@@ -3249,8 +3389,9 @@
           <a:bodyPr xmlns:a="http://schemas.openxmlformats.org/drawingml/2006/main" wrap="square" lIns="76200" tIns="38100" rIns="76200" bIns="38100" anchor="ctr"/>
           <a:lstStyle xmlns:a="http://schemas.openxmlformats.org/drawingml/2006/main"/>
           <a:p xmlns:a="http://schemas.openxmlformats.org/drawingml/2006/main">
-            <a:r>
-              <a:t>场景痛点</a:t>
+            <a:pPr/>
+            <a:r>
+              <a:t>目录</a:t>
             </a:r>
           </a:p>
         </p:txBody>
@@ -3283,8 +3424,9 @@
           <a:bodyPr xmlns:a="http://schemas.openxmlformats.org/drawingml/2006/main" wrap="square" lIns="0" tIns="0" rIns="76200" bIns="0" anchor="ctr"/>
           <a:lstStyle xmlns:a="http://schemas.openxmlformats.org/drawingml/2006/main"/>
           <a:p xmlns:a="http://schemas.openxmlformats.org/drawingml/2006/main">
-            <a:r>
-              <a:t>真正稀缺的不是论文数量，而是可复用的科研演化过程。</a:t>
+            <a:pPr/>
+            <a:r>
+              <a:t>评委可以按四个问题阅读这份材料。</a:t>
             </a:r>
           </a:p>
         </p:txBody>
@@ -3317,6 +3459,7 @@
           <a:bodyPr xmlns:a="http://schemas.openxmlformats.org/drawingml/2006/main" wrap="square" lIns="76200" tIns="38100" rIns="76200" bIns="38100" anchor="ctr"/>
           <a:lstStyle xmlns:a="http://schemas.openxmlformats.org/drawingml/2006/main"/>
           <a:p xmlns:a="http://schemas.openxmlformats.org/drawingml/2006/main">
+            <a:pPr/>
             <a:r>
               <a:t>Sci-Evo · LabTrace</a:t>
             </a:r>
@@ -3351,6 +3494,7 @@
           <a:bodyPr xmlns:a="http://schemas.openxmlformats.org/drawingml/2006/main" wrap="square" lIns="76200" tIns="38100" rIns="76200" bIns="38100" anchor="ctr"/>
           <a:lstStyle xmlns:a="http://schemas.openxmlformats.org/drawingml/2006/main"/>
           <a:p xmlns:a="http://schemas.openxmlformats.org/drawingml/2006/main">
+            <a:pPr/>
             <a:r>
               <a:t>02</a:t>
             </a:r>
@@ -3417,6 +3561,7 @@
           <a:bodyPr xmlns:a="http://schemas.openxmlformats.org/drawingml/2006/main" wrap="square" lIns="76200" tIns="38100" rIns="76200" bIns="38100" anchor="ctr"/>
           <a:lstStyle xmlns:a="http://schemas.openxmlformats.org/drawingml/2006/main"/>
           <a:p xmlns:a="http://schemas.openxmlformats.org/drawingml/2006/main">
+            <a:pPr/>
             <a:r>
               <a:t>01</a:t>
             </a:r>
@@ -3451,8 +3596,9 @@
           <a:bodyPr xmlns:a="http://schemas.openxmlformats.org/drawingml/2006/main" wrap="square" lIns="76200" tIns="38100" rIns="76200" bIns="38100" anchor="ctr"/>
           <a:lstStyle xmlns:a="http://schemas.openxmlformats.org/drawingml/2006/main"/>
           <a:p xmlns:a="http://schemas.openxmlformats.org/drawingml/2006/main">
-            <a:r>
-              <a:t>静态知识多</a:t>
+            <a:pPr/>
+            <a:r>
+              <a:t>为什么需要</a:t>
             </a:r>
           </a:p>
         </p:txBody>
@@ -3485,8 +3631,9 @@
           <a:bodyPr xmlns:a="http://schemas.openxmlformats.org/drawingml/2006/main" wrap="square" lIns="0" tIns="57150" rIns="76200" bIns="57150" anchor="ctr"/>
           <a:lstStyle xmlns:a="http://schemas.openxmlformats.org/drawingml/2006/main"/>
           <a:p xmlns:a="http://schemas.openxmlformats.org/drawingml/2006/main">
-            <a:r>
-              <a:t>现有语料大多只保留结论、摘要或问答，缺少真实科研步骤与决策上下文。</a:t>
+            <a:pPr/>
+            <a:r>
+              <a:t>论文结论很多，但可学习的科研过程数据仍然稀缺。</a:t>
             </a:r>
           </a:p>
         </p:txBody>
@@ -3519,6 +3666,7 @@
           <a:bodyPr xmlns:a="http://schemas.openxmlformats.org/drawingml/2006/main" wrap="square" lIns="76200" tIns="38100" rIns="76200" bIns="38100" anchor="ctr"/>
           <a:lstStyle xmlns:a="http://schemas.openxmlformats.org/drawingml/2006/main"/>
           <a:p xmlns:a="http://schemas.openxmlformats.org/drawingml/2006/main">
+            <a:pPr/>
             <a:r>
               <a:t>→</a:t>
             </a:r>
@@ -3585,6 +3733,7 @@
           <a:bodyPr xmlns:a="http://schemas.openxmlformats.org/drawingml/2006/main" wrap="square" lIns="76200" tIns="38100" rIns="76200" bIns="38100" anchor="ctr"/>
           <a:lstStyle xmlns:a="http://schemas.openxmlformats.org/drawingml/2006/main"/>
           <a:p xmlns:a="http://schemas.openxmlformats.org/drawingml/2006/main">
+            <a:pPr/>
             <a:r>
               <a:t>02</a:t>
             </a:r>
@@ -3619,8 +3768,9 @@
           <a:bodyPr xmlns:a="http://schemas.openxmlformats.org/drawingml/2006/main" wrap="square" lIns="76200" tIns="38100" rIns="76200" bIns="38100" anchor="ctr"/>
           <a:lstStyle xmlns:a="http://schemas.openxmlformats.org/drawingml/2006/main"/>
           <a:p xmlns:a="http://schemas.openxmlformats.org/drawingml/2006/main">
-            <a:r>
-              <a:t>证据链断</a:t>
+            <a:pPr/>
+            <a:r>
+              <a:t>证据怎么来</a:t>
             </a:r>
           </a:p>
         </p:txBody>
@@ -3653,8 +3803,9 @@
           <a:bodyPr xmlns:a="http://schemas.openxmlformats.org/drawingml/2006/main" wrap="square" lIns="0" tIns="57150" rIns="76200" bIns="57150" anchor="ctr"/>
           <a:lstStyle xmlns:a="http://schemas.openxmlformats.org/drawingml/2006/main"/>
           <a:p xmlns:a="http://schemas.openxmlformats.org/drawingml/2006/main">
-            <a:r>
-              <a:t>即使能读 PDF，也常停留在段落摘录，难以回溯到页面、图表和具体实验节点。</a:t>
+            <a:pPr/>
+            <a:r>
+              <a:t>MinerU 把 PDF 转成 Markdown、layout 和块级证据。</a:t>
             </a:r>
           </a:p>
         </p:txBody>
@@ -3687,6 +3838,7 @@
           <a:bodyPr xmlns:a="http://schemas.openxmlformats.org/drawingml/2006/main" wrap="square" lIns="76200" tIns="38100" rIns="76200" bIns="38100" anchor="ctr"/>
           <a:lstStyle xmlns:a="http://schemas.openxmlformats.org/drawingml/2006/main"/>
           <a:p xmlns:a="http://schemas.openxmlformats.org/drawingml/2006/main">
+            <a:pPr/>
             <a:r>
               <a:t>→</a:t>
             </a:r>
@@ -3753,6 +3905,7 @@
           <a:bodyPr xmlns:a="http://schemas.openxmlformats.org/drawingml/2006/main" wrap="square" lIns="76200" tIns="38100" rIns="76200" bIns="38100" anchor="ctr"/>
           <a:lstStyle xmlns:a="http://schemas.openxmlformats.org/drawingml/2006/main"/>
           <a:p xmlns:a="http://schemas.openxmlformats.org/drawingml/2006/main">
+            <a:pPr/>
             <a:r>
               <a:t>03</a:t>
             </a:r>
@@ -3787,8 +3940,9 @@
           <a:bodyPr xmlns:a="http://schemas.openxmlformats.org/drawingml/2006/main" wrap="square" lIns="76200" tIns="38100" rIns="76200" bIns="38100" anchor="ctr"/>
           <a:lstStyle xmlns:a="http://schemas.openxmlformats.org/drawingml/2006/main"/>
           <a:p xmlns:a="http://schemas.openxmlformats.org/drawingml/2006/main">
-            <a:r>
-              <a:t>审查成本高</a:t>
+            <a:pPr/>
+            <a:r>
+              <a:t>如何被验证</a:t>
             </a:r>
           </a:p>
         </p:txBody>
@@ -3821,8 +3975,9 @@
           <a:bodyPr xmlns:a="http://schemas.openxmlformats.org/drawingml/2006/main" wrap="square" lIns="0" tIns="57150" rIns="76200" bIns="57150" anchor="ctr"/>
           <a:lstStyle xmlns:a="http://schemas.openxmlformats.org/drawingml/2006/main"/>
           <a:p xmlns:a="http://schemas.openxmlformats.org/drawingml/2006/main">
-            <a:r>
-              <a:t>数据、报告、评测任务和许可说明分散，评委很难快速确认工程完整度。</a:t>
+            <a:pPr/>
+            <a:r>
+              <a:t>Schema、gold case、评测任务和报告共同证明质量。</a:t>
             </a:r>
           </a:p>
         </p:txBody>
@@ -3887,8 +4042,9 @@
           <a:bodyPr xmlns:a="http://schemas.openxmlformats.org/drawingml/2006/main" wrap="square" lIns="76200" tIns="38100" rIns="76200" bIns="38100" anchor="ctr"/>
           <a:lstStyle xmlns:a="http://schemas.openxmlformats.org/drawingml/2006/main"/>
           <a:p xmlns:a="http://schemas.openxmlformats.org/drawingml/2006/main">
-            <a:r>
-              <a:t>核心判断</a:t>
+            <a:pPr/>
+            <a:r>
+              <a:t>阅读主线</a:t>
             </a:r>
           </a:p>
         </p:txBody>
@@ -3921,8 +4077,9 @@
           <a:bodyPr xmlns:a="http://schemas.openxmlformats.org/drawingml/2006/main" wrap="square" lIns="76200" tIns="38100" rIns="76200" bIns="38100" anchor="ctr"/>
           <a:lstStyle xmlns:a="http://schemas.openxmlformats.org/drawingml/2006/main"/>
           <a:p xmlns:a="http://schemas.openxmlformats.org/drawingml/2006/main">
-            <a:r>
-              <a:t>高保真解析只是底座；更关键的是把科研轨迹、证据链、质量控制和评测机制做成闭环。</a:t>
+            <a:pPr/>
+            <a:r>
+              <a:t>问题定义 → MinerU 证据 → 数据结构 → 质量验证 → 后续扩展。</a:t>
             </a:r>
           </a:p>
         </p:txBody>
@@ -4048,8 +4205,9 @@
           <a:bodyPr xmlns:a="http://schemas.openxmlformats.org/drawingml/2006/main" wrap="square" lIns="76200" tIns="38100" rIns="76200" bIns="38100" anchor="ctr"/>
           <a:lstStyle xmlns:a="http://schemas.openxmlformats.org/drawingml/2006/main"/>
           <a:p xmlns:a="http://schemas.openxmlformats.org/drawingml/2006/main">
-            <a:r>
-              <a:t>系统架构</a:t>
+            <a:pPr/>
+            <a:r>
+              <a:t>主线架构</a:t>
             </a:r>
           </a:p>
         </p:txBody>
@@ -4082,8 +4240,9 @@
           <a:bodyPr xmlns:a="http://schemas.openxmlformats.org/drawingml/2006/main" wrap="square" lIns="0" tIns="0" rIns="76200" bIns="0" anchor="ctr"/>
           <a:lstStyle xmlns:a="http://schemas.openxmlformats.org/drawingml/2006/main"/>
           <a:p xmlns:a="http://schemas.openxmlformats.org/drawingml/2006/main">
-            <a:r>
-              <a:t>先把论文解析成可信证据，再构建科研轨迹数据。</a:t>
+            <a:pPr/>
+            <a:r>
+              <a:t>先把论文变成可信证据，再把证据组织成科研轨迹。</a:t>
             </a:r>
           </a:p>
         </p:txBody>
@@ -4116,6 +4275,7 @@
           <a:bodyPr xmlns:a="http://schemas.openxmlformats.org/drawingml/2006/main" wrap="square" lIns="76200" tIns="38100" rIns="76200" bIns="38100" anchor="ctr"/>
           <a:lstStyle xmlns:a="http://schemas.openxmlformats.org/drawingml/2006/main"/>
           <a:p xmlns:a="http://schemas.openxmlformats.org/drawingml/2006/main">
+            <a:pPr/>
             <a:r>
               <a:t>Sci-Evo · LabTrace</a:t>
             </a:r>
@@ -4150,6 +4310,7 @@
           <a:bodyPr xmlns:a="http://schemas.openxmlformats.org/drawingml/2006/main" wrap="square" lIns="76200" tIns="38100" rIns="76200" bIns="38100" anchor="ctr"/>
           <a:lstStyle xmlns:a="http://schemas.openxmlformats.org/drawingml/2006/main"/>
           <a:p xmlns:a="http://schemas.openxmlformats.org/drawingml/2006/main">
+            <a:pPr/>
             <a:r>
               <a:t>03</a:t>
             </a:r>
@@ -4216,6 +4377,7 @@
           <a:bodyPr xmlns:a="http://schemas.openxmlformats.org/drawingml/2006/main" wrap="square" lIns="76200" tIns="38100" rIns="76200" bIns="38100" anchor="ctr"/>
           <a:lstStyle xmlns:a="http://schemas.openxmlformats.org/drawingml/2006/main"/>
           <a:p xmlns:a="http://schemas.openxmlformats.org/drawingml/2006/main">
+            <a:pPr/>
             <a:r>
               <a:t>输入</a:t>
             </a:r>
@@ -4250,6 +4412,7 @@
           <a:bodyPr xmlns:a="http://schemas.openxmlformats.org/drawingml/2006/main" wrap="square" lIns="76200" tIns="38100" rIns="76200" bIns="38100" anchor="ctr"/>
           <a:lstStyle xmlns:a="http://schemas.openxmlformats.org/drawingml/2006/main"/>
           <a:p xmlns:a="http://schemas.openxmlformats.org/drawingml/2006/main">
+            <a:pPr/>
             <a:r>
               <a:t>PDF / DOI / 许可信息</a:t>
             </a:r>
@@ -4284,6 +4447,7 @@
           <a:bodyPr xmlns:a="http://schemas.openxmlformats.org/drawingml/2006/main" wrap="square" lIns="76200" tIns="38100" rIns="76200" bIns="38100" anchor="ctr"/>
           <a:lstStyle xmlns:a="http://schemas.openxmlformats.org/drawingml/2006/main"/>
           <a:p xmlns:a="http://schemas.openxmlformats.org/drawingml/2006/main">
+            <a:pPr/>
             <a:r>
               <a:t>→</a:t>
             </a:r>
@@ -4350,6 +4514,7 @@
           <a:bodyPr xmlns:a="http://schemas.openxmlformats.org/drawingml/2006/main" wrap="square" lIns="76200" tIns="38100" rIns="76200" bIns="38100" anchor="ctr"/>
           <a:lstStyle xmlns:a="http://schemas.openxmlformats.org/drawingml/2006/main"/>
           <a:p xmlns:a="http://schemas.openxmlformats.org/drawingml/2006/main">
+            <a:pPr/>
             <a:r>
               <a:t>解析</a:t>
             </a:r>
@@ -4384,6 +4549,7 @@
           <a:bodyPr xmlns:a="http://schemas.openxmlformats.org/drawingml/2006/main" wrap="square" lIns="76200" tIns="38100" rIns="76200" bIns="38100" anchor="ctr"/>
           <a:lstStyle xmlns:a="http://schemas.openxmlformats.org/drawingml/2006/main"/>
           <a:p xmlns:a="http://schemas.openxmlformats.org/drawingml/2006/main">
+            <a:pPr/>
             <a:r>
               <a:t>MinerU / Markdown / layout</a:t>
             </a:r>
@@ -4418,6 +4584,7 @@
           <a:bodyPr xmlns:a="http://schemas.openxmlformats.org/drawingml/2006/main" wrap="square" lIns="76200" tIns="38100" rIns="76200" bIns="38100" anchor="ctr"/>
           <a:lstStyle xmlns:a="http://schemas.openxmlformats.org/drawingml/2006/main"/>
           <a:p xmlns:a="http://schemas.openxmlformats.org/drawingml/2006/main">
+            <a:pPr/>
             <a:r>
               <a:t>→</a:t>
             </a:r>
@@ -4484,6 +4651,7 @@
           <a:bodyPr xmlns:a="http://schemas.openxmlformats.org/drawingml/2006/main" wrap="square" lIns="76200" tIns="38100" rIns="76200" bIns="38100" anchor="ctr"/>
           <a:lstStyle xmlns:a="http://schemas.openxmlformats.org/drawingml/2006/main"/>
           <a:p xmlns:a="http://schemas.openxmlformats.org/drawingml/2006/main">
+            <a:pPr/>
             <a:r>
               <a:t>建模</a:t>
             </a:r>
@@ -4518,6 +4686,7 @@
           <a:bodyPr xmlns:a="http://schemas.openxmlformats.org/drawingml/2006/main" wrap="square" lIns="76200" tIns="38100" rIns="76200" bIns="38100" anchor="ctr"/>
           <a:lstStyle xmlns:a="http://schemas.openxmlformats.org/drawingml/2006/main"/>
           <a:p xmlns:a="http://schemas.openxmlformats.org/drawingml/2006/main">
+            <a:pPr/>
             <a:r>
               <a:t>case schema / evidence map</a:t>
             </a:r>
@@ -4552,6 +4721,7 @@
           <a:bodyPr xmlns:a="http://schemas.openxmlformats.org/drawingml/2006/main" wrap="square" lIns="76200" tIns="38100" rIns="76200" bIns="38100" anchor="ctr"/>
           <a:lstStyle xmlns:a="http://schemas.openxmlformats.org/drawingml/2006/main"/>
           <a:p xmlns:a="http://schemas.openxmlformats.org/drawingml/2006/main">
+            <a:pPr/>
             <a:r>
               <a:t>→</a:t>
             </a:r>
@@ -4618,6 +4788,7 @@
           <a:bodyPr xmlns:a="http://schemas.openxmlformats.org/drawingml/2006/main" wrap="square" lIns="76200" tIns="38100" rIns="76200" bIns="38100" anchor="ctr"/>
           <a:lstStyle xmlns:a="http://schemas.openxmlformats.org/drawingml/2006/main"/>
           <a:p xmlns:a="http://schemas.openxmlformats.org/drawingml/2006/main">
+            <a:pPr/>
             <a:r>
               <a:t>抽取</a:t>
             </a:r>
@@ -4652,6 +4823,7 @@
           <a:bodyPr xmlns:a="http://schemas.openxmlformats.org/drawingml/2006/main" wrap="square" lIns="76200" tIns="38100" rIns="76200" bIns="38100" anchor="ctr"/>
           <a:lstStyle xmlns:a="http://schemas.openxmlformats.org/drawingml/2006/main"/>
           <a:p xmlns:a="http://schemas.openxmlformats.org/drawingml/2006/main">
+            <a:pPr/>
             <a:r>
               <a:t>trajectory / verification</a:t>
             </a:r>
@@ -4686,6 +4858,7 @@
           <a:bodyPr xmlns:a="http://schemas.openxmlformats.org/drawingml/2006/main" wrap="square" lIns="76200" tIns="38100" rIns="76200" bIns="38100" anchor="ctr"/>
           <a:lstStyle xmlns:a="http://schemas.openxmlformats.org/drawingml/2006/main"/>
           <a:p xmlns:a="http://schemas.openxmlformats.org/drawingml/2006/main">
+            <a:pPr/>
             <a:r>
               <a:t>→</a:t>
             </a:r>
@@ -4752,6 +4925,7 @@
           <a:bodyPr xmlns:a="http://schemas.openxmlformats.org/drawingml/2006/main" wrap="square" lIns="76200" tIns="38100" rIns="76200" bIns="38100" anchor="ctr"/>
           <a:lstStyle xmlns:a="http://schemas.openxmlformats.org/drawingml/2006/main"/>
           <a:p xmlns:a="http://schemas.openxmlformats.org/drawingml/2006/main">
+            <a:pPr/>
             <a:r>
               <a:t>产出</a:t>
             </a:r>
@@ -4786,6 +4960,7 @@
           <a:bodyPr xmlns:a="http://schemas.openxmlformats.org/drawingml/2006/main" wrap="square" lIns="76200" tIns="38100" rIns="76200" bIns="38100" anchor="ctr"/>
           <a:lstStyle xmlns:a="http://schemas.openxmlformats.org/drawingml/2006/main"/>
           <a:p xmlns:a="http://schemas.openxmlformats.org/drawingml/2006/main">
+            <a:pPr/>
             <a:r>
               <a:t>JSONL / tasks / reports</a:t>
             </a:r>
@@ -4852,6 +5027,7 @@
           <a:bodyPr xmlns:a="http://schemas.openxmlformats.org/drawingml/2006/main" wrap="square" lIns="76200" tIns="38100" rIns="76200" bIns="38100" anchor="ctr"/>
           <a:lstStyle xmlns:a="http://schemas.openxmlformats.org/drawingml/2006/main"/>
           <a:p xmlns:a="http://schemas.openxmlformats.org/drawingml/2006/main">
+            <a:pPr/>
             <a:r>
               <a:t>统一证据链</a:t>
             </a:r>
@@ -4886,6 +5062,7 @@
           <a:bodyPr xmlns:a="http://schemas.openxmlformats.org/drawingml/2006/main" wrap="square" lIns="0" tIns="57150" rIns="76200" bIns="57150" anchor="ctr"/>
           <a:lstStyle xmlns:a="http://schemas.openxmlformats.org/drawingml/2006/main"/>
           <a:p xmlns:a="http://schemas.openxmlformats.org/drawingml/2006/main">
+            <a:pPr/>
             <a:r>
               <a:t>每个轨迹步骤保留来源页码、定位文本和 MinerU block 对应关系。</a:t>
             </a:r>
@@ -4952,6 +5129,7 @@
           <a:bodyPr xmlns:a="http://schemas.openxmlformats.org/drawingml/2006/main" wrap="square" lIns="76200" tIns="38100" rIns="76200" bIns="38100" anchor="ctr"/>
           <a:lstStyle xmlns:a="http://schemas.openxmlformats.org/drawingml/2006/main"/>
           <a:p xmlns:a="http://schemas.openxmlformats.org/drawingml/2006/main">
+            <a:pPr/>
             <a:r>
               <a:t>统一工程闭环</a:t>
             </a:r>
@@ -4986,6 +5164,7 @@
           <a:bodyPr xmlns:a="http://schemas.openxmlformats.org/drawingml/2006/main" wrap="square" lIns="0" tIns="57150" rIns="76200" bIns="57150" anchor="ctr"/>
           <a:lstStyle xmlns:a="http://schemas.openxmlformats.org/drawingml/2006/main"/>
           <a:p xmlns:a="http://schemas.openxmlformats.org/drawingml/2006/main">
+            <a:pPr/>
             <a:r>
               <a:t>构建、校验、质量报告和一致性检查共同保证材料可复核、可扩展。</a:t>
             </a:r>
@@ -5113,8 +5292,9 @@
           <a:bodyPr xmlns:a="http://schemas.openxmlformats.org/drawingml/2006/main" wrap="square" lIns="76200" tIns="38100" rIns="76200" bIns="38100" anchor="ctr"/>
           <a:lstStyle xmlns:a="http://schemas.openxmlformats.org/drawingml/2006/main"/>
           <a:p xmlns:a="http://schemas.openxmlformats.org/drawingml/2006/main">
-            <a:r>
-              <a:t>MINERU 解析</a:t>
+            <a:pPr/>
+            <a:r>
+              <a:t>证据来源</a:t>
             </a:r>
           </a:p>
         </p:txBody>
@@ -5147,8 +5327,9 @@
           <a:bodyPr xmlns:a="http://schemas.openxmlformats.org/drawingml/2006/main" wrap="square" lIns="0" tIns="0" rIns="76200" bIns="0" anchor="ctr"/>
           <a:lstStyle xmlns:a="http://schemas.openxmlformats.org/drawingml/2006/main"/>
           <a:p xmlns:a="http://schemas.openxmlformats.org/drawingml/2006/main">
-            <a:r>
-              <a:t>第一公里有真实落地：本地产物、页级证据和复现实验路径都可检查。</a:t>
+            <a:pPr/>
+            <a:r>
+              <a:t>MinerU 不是展示点，而是每条轨迹可追溯的第一公里。</a:t>
             </a:r>
           </a:p>
         </p:txBody>
@@ -5181,6 +5362,7 @@
           <a:bodyPr xmlns:a="http://schemas.openxmlformats.org/drawingml/2006/main" wrap="square" lIns="76200" tIns="38100" rIns="76200" bIns="38100" anchor="ctr"/>
           <a:lstStyle xmlns:a="http://schemas.openxmlformats.org/drawingml/2006/main"/>
           <a:p xmlns:a="http://schemas.openxmlformats.org/drawingml/2006/main">
+            <a:pPr/>
             <a:r>
               <a:t>Sci-Evo · LabTrace</a:t>
             </a:r>
@@ -5215,6 +5397,7 @@
           <a:bodyPr xmlns:a="http://schemas.openxmlformats.org/drawingml/2006/main" wrap="square" lIns="76200" tIns="38100" rIns="76200" bIns="38100" anchor="ctr"/>
           <a:lstStyle xmlns:a="http://schemas.openxmlformats.org/drawingml/2006/main"/>
           <a:p xmlns:a="http://schemas.openxmlformats.org/drawingml/2006/main">
+            <a:pPr/>
             <a:r>
               <a:t>04</a:t>
             </a:r>
@@ -5281,6 +5464,7 @@
           <a:bodyPr xmlns:a="http://schemas.openxmlformats.org/drawingml/2006/main" wrap="square" lIns="0" tIns="0" rIns="0" bIns="0" anchor="ctr"/>
           <a:lstStyle xmlns:a="http://schemas.openxmlformats.org/drawingml/2006/main"/>
           <a:p xmlns:a="http://schemas.openxmlformats.org/drawingml/2006/main">
+            <a:pPr/>
             <a:r>
               <a:t>1</a:t>
             </a:r>
@@ -5315,6 +5499,7 @@
           <a:bodyPr xmlns:a="http://schemas.openxmlformats.org/drawingml/2006/main" wrap="square" lIns="0" tIns="0" rIns="0" bIns="0" anchor="ctr"/>
           <a:lstStyle xmlns:a="http://schemas.openxmlformats.org/drawingml/2006/main"/>
           <a:p xmlns:a="http://schemas.openxmlformats.org/drawingml/2006/main">
+            <a:pPr/>
             <a:r>
               <a:t>本地解析样例</a:t>
             </a:r>
@@ -5381,6 +5566,7 @@
           <a:bodyPr xmlns:a="http://schemas.openxmlformats.org/drawingml/2006/main" wrap="square" lIns="0" tIns="0" rIns="0" bIns="0" anchor="ctr"/>
           <a:lstStyle xmlns:a="http://schemas.openxmlformats.org/drawingml/2006/main"/>
           <a:p xmlns:a="http://schemas.openxmlformats.org/drawingml/2006/main">
+            <a:pPr/>
             <a:r>
               <a:t>5</a:t>
             </a:r>
@@ -5415,6 +5601,7 @@
           <a:bodyPr xmlns:a="http://schemas.openxmlformats.org/drawingml/2006/main" wrap="square" lIns="0" tIns="0" rIns="0" bIns="0" anchor="ctr"/>
           <a:lstStyle xmlns:a="http://schemas.openxmlformats.org/drawingml/2006/main"/>
           <a:p xmlns:a="http://schemas.openxmlformats.org/drawingml/2006/main">
+            <a:pPr/>
             <a:r>
               <a:t>核心产物类型</a:t>
             </a:r>
@@ -5481,6 +5668,7 @@
           <a:bodyPr xmlns:a="http://schemas.openxmlformats.org/drawingml/2006/main" wrap="square" lIns="0" tIns="0" rIns="0" bIns="0" anchor="ctr"/>
           <a:lstStyle xmlns:a="http://schemas.openxmlformats.org/drawingml/2006/main"/>
           <a:p xmlns:a="http://schemas.openxmlformats.org/drawingml/2006/main">
+            <a:pPr/>
             <a:r>
               <a:t>100%</a:t>
             </a:r>
@@ -5515,6 +5703,7 @@
           <a:bodyPr xmlns:a="http://schemas.openxmlformats.org/drawingml/2006/main" wrap="square" lIns="0" tIns="0" rIns="0" bIns="0" anchor="ctr"/>
           <a:lstStyle xmlns:a="http://schemas.openxmlformats.org/drawingml/2006/main"/>
           <a:p xmlns:a="http://schemas.openxmlformats.org/drawingml/2006/main">
+            <a:pPr/>
             <a:r>
               <a:t>样例可复查</a:t>
             </a:r>
@@ -5581,8 +5770,9 @@
           <a:bodyPr xmlns:a="http://schemas.openxmlformats.org/drawingml/2006/main" wrap="square" lIns="76200" tIns="38100" rIns="76200" bIns="38100" anchor="ctr"/>
           <a:lstStyle xmlns:a="http://schemas.openxmlformats.org/drawingml/2006/main"/>
           <a:p xmlns:a="http://schemas.openxmlformats.org/drawingml/2006/main">
-            <a:r>
-              <a:t>本地运行报告已保存</a:t>
+            <a:pPr/>
+            <a:r>
+              <a:t>MinerU 本地产物</a:t>
             </a:r>
           </a:p>
         </p:txBody>
@@ -5615,8 +5805,9 @@
           <a:bodyPr xmlns:a="http://schemas.openxmlformats.org/drawingml/2006/main" wrap="square" lIns="76200" tIns="38100" rIns="76200" bIns="38100" anchor="ctr"/>
           <a:lstStyle xmlns:a="http://schemas.openxmlformats.org/drawingml/2006/main"/>
           <a:p xmlns:a="http://schemas.openxmlformats.org/drawingml/2006/main">
-            <a:r>
-              <a:t>输入样例</a:t>
+            <a:pPr/>
+            <a:r>
+              <a:t>输入</a:t>
             </a:r>
           </a:p>
         </p:txBody>
@@ -5649,8 +5840,9 @@
           <a:bodyPr xmlns:a="http://schemas.openxmlformats.org/drawingml/2006/main" wrap="square" lIns="76200" tIns="38100" rIns="76200" bIns="38100" anchor="ctr"/>
           <a:lstStyle xmlns:a="http://schemas.openxmlformats.org/drawingml/2006/main"/>
           <a:p xmlns:a="http://schemas.openxmlformats.org/drawingml/2006/main">
-            <a:r>
-              <a:t>Sci-Evo-Sample.pdf</a:t>
+            <a:pPr/>
+            <a:r>
+              <a:t>样例 PDF</a:t>
             </a:r>
           </a:p>
         </p:txBody>
@@ -5683,8 +5875,9 @@
           <a:bodyPr xmlns:a="http://schemas.openxmlformats.org/drawingml/2006/main" wrap="square" lIns="76200" tIns="38100" rIns="76200" bIns="38100" anchor="ctr"/>
           <a:lstStyle xmlns:a="http://schemas.openxmlformats.org/drawingml/2006/main"/>
           <a:p xmlns:a="http://schemas.openxmlformats.org/drawingml/2006/main">
-            <a:r>
-              <a:t>产物覆盖</a:t>
+            <a:pPr/>
+            <a:r>
+              <a:t>产物</a:t>
             </a:r>
           </a:p>
         </p:txBody>
@@ -5717,8 +5910,9 @@
           <a:bodyPr xmlns:a="http://schemas.openxmlformats.org/drawingml/2006/main" wrap="square" lIns="76200" tIns="38100" rIns="76200" bIns="38100" anchor="ctr"/>
           <a:lstStyle xmlns:a="http://schemas.openxmlformats.org/drawingml/2006/main"/>
           <a:p xmlns:a="http://schemas.openxmlformats.org/drawingml/2006/main">
-            <a:r>
-              <a:t>full.md / layout.json / content_list</a:t>
+            <a:pPr/>
+            <a:r>
+              <a:t>md / layout</a:t>
             </a:r>
           </a:p>
         </p:txBody>
@@ -5751,8 +5945,9 @@
           <a:bodyPr xmlns:a="http://schemas.openxmlformats.org/drawingml/2006/main" wrap="square" lIns="76200" tIns="38100" rIns="76200" bIns="38100" anchor="ctr"/>
           <a:lstStyle xmlns:a="http://schemas.openxmlformats.org/drawingml/2006/main"/>
           <a:p xmlns:a="http://schemas.openxmlformats.org/drawingml/2006/main">
-            <a:r>
-              <a:t>关键文件</a:t>
+            <a:pPr/>
+            <a:r>
+              <a:t>证据</a:t>
             </a:r>
           </a:p>
         </p:txBody>
@@ -5785,8 +5980,9 @@
           <a:bodyPr xmlns:a="http://schemas.openxmlformats.org/drawingml/2006/main" wrap="square" lIns="76200" tIns="38100" rIns="76200" bIns="38100" anchor="ctr"/>
           <a:lstStyle xmlns:a="http://schemas.openxmlformats.org/drawingml/2006/main"/>
           <a:p xmlns:a="http://schemas.openxmlformats.org/drawingml/2006/main">
-            <a:r>
-              <a:t>markdown / json / model / images</a:t>
+            <a:pPr/>
+            <a:r>
+              <a:t>页码 / block</a:t>
             </a:r>
           </a:p>
         </p:txBody>
@@ -5819,8 +6015,9 @@
           <a:bodyPr xmlns:a="http://schemas.openxmlformats.org/drawingml/2006/main" wrap="square" lIns="76200" tIns="38100" rIns="76200" bIns="38100" anchor="ctr"/>
           <a:lstStyle xmlns:a="http://schemas.openxmlformats.org/drawingml/2006/main"/>
           <a:p xmlns:a="http://schemas.openxmlformats.org/drawingml/2006/main">
-            <a:r>
-              <a:t>许可边界</a:t>
+            <a:pPr/>
+            <a:r>
+              <a:t>边界</a:t>
             </a:r>
           </a:p>
         </p:txBody>
@@ -5853,8 +6050,9 @@
           <a:bodyPr xmlns:a="http://schemas.openxmlformats.org/drawingml/2006/main" wrap="square" lIns="76200" tIns="38100" rIns="76200" bIns="38100" anchor="ctr"/>
           <a:lstStyle xmlns:a="http://schemas.openxmlformats.org/drawingml/2006/main"/>
           <a:p xmlns:a="http://schemas.openxmlformats.org/drawingml/2006/main">
-            <a:r>
-              <a:t>全文级解析产物仅本地保留</a:t>
+            <a:pPr/>
+            <a:r>
+              <a:t>全文本地留存</a:t>
             </a:r>
           </a:p>
         </p:txBody>
@@ -5887,8 +6085,9 @@
           <a:bodyPr xmlns:a="http://schemas.openxmlformats.org/drawingml/2006/main" wrap="square" lIns="76200" tIns="38100" rIns="76200" bIns="38100" anchor="ctr"/>
           <a:lstStyle xmlns:a="http://schemas.openxmlformats.org/drawingml/2006/main"/>
           <a:p xmlns:a="http://schemas.openxmlformats.org/drawingml/2006/main">
-            <a:r>
-              <a:t>后续扩展</a:t>
+            <a:pPr/>
+            <a:r>
+              <a:t>扩展</a:t>
             </a:r>
           </a:p>
         </p:txBody>
@@ -5921,8 +6120,9 @@
           <a:bodyPr xmlns:a="http://schemas.openxmlformats.org/drawingml/2006/main" wrap="square" lIns="76200" tIns="38100" rIns="76200" bIns="38100" anchor="ctr"/>
           <a:lstStyle xmlns:a="http://schemas.openxmlformats.org/drawingml/2006/main"/>
           <a:p xmlns:a="http://schemas.openxmlformats.org/drawingml/2006/main">
-            <a:r>
-              <a:t>开放论文可继续补齐本地 MinerU 解析结果</a:t>
+            <a:pPr/>
+            <a:r>
+              <a:t>开放论文补解析</a:t>
             </a:r>
           </a:p>
         </p:txBody>
@@ -5955,8 +6155,9 @@
           <a:bodyPr xmlns:a="http://schemas.openxmlformats.org/drawingml/2006/main" wrap="square" lIns="0" tIns="57150" rIns="76200" bIns="57150" anchor="ctr"/>
           <a:lstStyle xmlns:a="http://schemas.openxmlformats.org/drawingml/2006/main"/>
           <a:p xmlns:a="http://schemas.openxmlformats.org/drawingml/2006/main">
-            <a:r>
-              <a:t>使用方式：通过 scripts/mineru_parse.py 调用 MinerU API，本地保留 Markdown、content list、layout、model 与图片；因许可约束，不公开未复核全文级产物。</a:t>
+            <a:pPr/>
+            <a:r>
+              <a:t>复核方式：关键字段回到 PDF 页面、Markdown 段落或 layout 块；全文级产物因许可仅本地留存。</a:t>
             </a:r>
           </a:p>
         </p:txBody>
@@ -6082,8 +6283,9 @@
           <a:bodyPr xmlns:a="http://schemas.openxmlformats.org/drawingml/2006/main" wrap="square" lIns="76200" tIns="38100" rIns="76200" bIns="38100" anchor="ctr"/>
           <a:lstStyle xmlns:a="http://schemas.openxmlformats.org/drawingml/2006/main"/>
           <a:p xmlns:a="http://schemas.openxmlformats.org/drawingml/2006/main">
-            <a:r>
-              <a:t>数据总览</a:t>
+            <a:pPr/>
+            <a:r>
+              <a:t>数据内容</a:t>
             </a:r>
           </a:p>
         </p:txBody>
@@ -6116,8 +6318,9 @@
           <a:bodyPr xmlns:a="http://schemas.openxmlformats.org/drawingml/2006/main" wrap="square" lIns="0" tIns="0" rIns="76200" bIns="0" anchor="ctr"/>
           <a:lstStyle xmlns:a="http://schemas.openxmlformats.org/drawingml/2006/main"/>
           <a:p xmlns:a="http://schemas.openxmlformats.org/drawingml/2006/main">
-            <a:r>
-              <a:t>每条 case 同时呈现领域、轨迹重心、许可状态和关键证据。</a:t>
+            <a:pPr/>
+            <a:r>
+              <a:t>当前 3 条 gold case 覆盖样例、开放论文和后续候选队列。</a:t>
             </a:r>
           </a:p>
         </p:txBody>
@@ -6150,6 +6353,7 @@
           <a:bodyPr xmlns:a="http://schemas.openxmlformats.org/drawingml/2006/main" wrap="square" lIns="76200" tIns="38100" rIns="76200" bIns="38100" anchor="ctr"/>
           <a:lstStyle xmlns:a="http://schemas.openxmlformats.org/drawingml/2006/main"/>
           <a:p xmlns:a="http://schemas.openxmlformats.org/drawingml/2006/main">
+            <a:pPr/>
             <a:r>
               <a:t>Sci-Evo · LabTrace</a:t>
             </a:r>
@@ -6184,6 +6388,7 @@
           <a:bodyPr xmlns:a="http://schemas.openxmlformats.org/drawingml/2006/main" wrap="square" lIns="76200" tIns="38100" rIns="76200" bIns="38100" anchor="ctr"/>
           <a:lstStyle xmlns:a="http://schemas.openxmlformats.org/drawingml/2006/main"/>
           <a:p xmlns:a="http://schemas.openxmlformats.org/drawingml/2006/main">
+            <a:pPr/>
             <a:r>
               <a:t>05</a:t>
             </a:r>
@@ -6250,6 +6455,7 @@
           <a:bodyPr xmlns:a="http://schemas.openxmlformats.org/drawingml/2006/main" wrap="square" lIns="76200" tIns="38100" rIns="76200" bIns="38100" anchor="ctr"/>
           <a:lstStyle xmlns:a="http://schemas.openxmlformats.org/drawingml/2006/main"/>
           <a:p xmlns:a="http://schemas.openxmlformats.org/drawingml/2006/main">
+            <a:pPr/>
             <a:r>
               <a:t>样本</a:t>
             </a:r>
@@ -6316,6 +6522,7 @@
           <a:bodyPr xmlns:a="http://schemas.openxmlformats.org/drawingml/2006/main" wrap="square" lIns="76200" tIns="38100" rIns="76200" bIns="38100" anchor="ctr"/>
           <a:lstStyle xmlns:a="http://schemas.openxmlformats.org/drawingml/2006/main"/>
           <a:p xmlns:a="http://schemas.openxmlformats.org/drawingml/2006/main">
+            <a:pPr/>
             <a:r>
               <a:t>领域</a:t>
             </a:r>
@@ -6382,6 +6589,7 @@
           <a:bodyPr xmlns:a="http://schemas.openxmlformats.org/drawingml/2006/main" wrap="square" lIns="76200" tIns="38100" rIns="76200" bIns="38100" anchor="ctr"/>
           <a:lstStyle xmlns:a="http://schemas.openxmlformats.org/drawingml/2006/main"/>
           <a:p xmlns:a="http://schemas.openxmlformats.org/drawingml/2006/main">
+            <a:pPr/>
             <a:r>
               <a:t>轨迹重心</a:t>
             </a:r>
@@ -6448,6 +6656,7 @@
           <a:bodyPr xmlns:a="http://schemas.openxmlformats.org/drawingml/2006/main" wrap="square" lIns="76200" tIns="38100" rIns="76200" bIns="38100" anchor="ctr"/>
           <a:lstStyle xmlns:a="http://schemas.openxmlformats.org/drawingml/2006/main"/>
           <a:p xmlns:a="http://schemas.openxmlformats.org/drawingml/2006/main">
+            <a:pPr/>
             <a:r>
               <a:t>许可状态</a:t>
             </a:r>
@@ -6514,6 +6723,7 @@
           <a:bodyPr xmlns:a="http://schemas.openxmlformats.org/drawingml/2006/main" wrap="square" lIns="76200" tIns="38100" rIns="76200" bIns="38100" anchor="ctr"/>
           <a:lstStyle xmlns:a="http://schemas.openxmlformats.org/drawingml/2006/main"/>
           <a:p xmlns:a="http://schemas.openxmlformats.org/drawingml/2006/main">
+            <a:pPr/>
             <a:r>
               <a:t>关键证据</a:t>
             </a:r>
@@ -6580,6 +6790,7 @@
           <a:bodyPr xmlns:a="http://schemas.openxmlformats.org/drawingml/2006/main" wrap="square" lIns="76200" tIns="38100" rIns="76200" bIns="38100" anchor="ctr"/>
           <a:lstStyle xmlns:a="http://schemas.openxmlformats.org/drawingml/2006/main"/>
           <a:p xmlns:a="http://schemas.openxmlformats.org/drawingml/2006/main">
+            <a:pPr/>
             <a:r>
               <a:t>de_novo_luciferase</a:t>
             </a:r>
@@ -6646,6 +6857,7 @@
           <a:bodyPr xmlns:a="http://schemas.openxmlformats.org/drawingml/2006/main" wrap="square" lIns="76200" tIns="38100" rIns="76200" bIns="38100" anchor="ctr"/>
           <a:lstStyle xmlns:a="http://schemas.openxmlformats.org/drawingml/2006/main"/>
           <a:p xmlns:a="http://schemas.openxmlformats.org/drawingml/2006/main">
+            <a:pPr/>
             <a:r>
               <a:t>生物发光</a:t>
             </a:r>
@@ -6712,6 +6924,7 @@
           <a:bodyPr xmlns:a="http://schemas.openxmlformats.org/drawingml/2006/main" wrap="square" lIns="76200" tIns="38100" rIns="76200" bIns="38100" anchor="ctr"/>
           <a:lstStyle xmlns:a="http://schemas.openxmlformats.org/drawingml/2006/main"/>
           <a:p xmlns:a="http://schemas.openxmlformats.org/drawingml/2006/main">
+            <a:pPr/>
             <a:r>
               <a:t>从头设计 + 筛选</a:t>
             </a:r>
@@ -6778,6 +6991,7 @@
           <a:bodyPr xmlns:a="http://schemas.openxmlformats.org/drawingml/2006/main" wrap="square" lIns="76200" tIns="38100" rIns="76200" bIns="38100" anchor="ctr"/>
           <a:lstStyle xmlns:a="http://schemas.openxmlformats.org/drawingml/2006/main"/>
           <a:p xmlns:a="http://schemas.openxmlformats.org/drawingml/2006/main">
+            <a:pPr/>
             <a:r>
               <a:t>种子样例</a:t>
             </a:r>
@@ -6844,6 +7058,7 @@
           <a:bodyPr xmlns:a="http://schemas.openxmlformats.org/drawingml/2006/main" wrap="square" lIns="76200" tIns="38100" rIns="76200" bIns="38100" anchor="ctr"/>
           <a:lstStyle xmlns:a="http://schemas.openxmlformats.org/drawingml/2006/main"/>
           <a:p xmlns:a="http://schemas.openxmlformats.org/drawingml/2006/main">
+            <a:pPr/>
             <a:r>
               <a:t>目标、突变、细胞验证</a:t>
             </a:r>
@@ -6910,6 +7125,7 @@
           <a:bodyPr xmlns:a="http://schemas.openxmlformats.org/drawingml/2006/main" wrap="square" lIns="76200" tIns="38100" rIns="76200" bIns="38100" anchor="ctr"/>
           <a:lstStyle xmlns:a="http://schemas.openxmlformats.org/drawingml/2006/main"/>
           <a:p xmlns:a="http://schemas.openxmlformats.org/drawingml/2006/main">
+            <a:pPr/>
             <a:r>
               <a:t>ml_enzyme_opt</a:t>
             </a:r>
@@ -6976,6 +7192,7 @@
           <a:bodyPr xmlns:a="http://schemas.openxmlformats.org/drawingml/2006/main" wrap="square" lIns="76200" tIns="38100" rIns="76200" bIns="38100" anchor="ctr"/>
           <a:lstStyle xmlns:a="http://schemas.openxmlformats.org/drawingml/2006/main"/>
           <a:p xmlns:a="http://schemas.openxmlformats.org/drawingml/2006/main">
+            <a:pPr/>
             <a:r>
               <a:t>酶工程</a:t>
             </a:r>
@@ -7042,6 +7259,7 @@
           <a:bodyPr xmlns:a="http://schemas.openxmlformats.org/drawingml/2006/main" wrap="square" lIns="76200" tIns="38100" rIns="76200" bIns="38100" anchor="ctr"/>
           <a:lstStyle xmlns:a="http://schemas.openxmlformats.org/drawingml/2006/main"/>
           <a:p xmlns:a="http://schemas.openxmlformats.org/drawingml/2006/main">
+            <a:pPr/>
             <a:r>
               <a:t>ML 设计 + 活性优化</a:t>
             </a:r>
@@ -7108,6 +7326,7 @@
           <a:bodyPr xmlns:a="http://schemas.openxmlformats.org/drawingml/2006/main" wrap="square" lIns="76200" tIns="38100" rIns="76200" bIns="38100" anchor="ctr"/>
           <a:lstStyle xmlns:a="http://schemas.openxmlformats.org/drawingml/2006/main"/>
           <a:p xmlns:a="http://schemas.openxmlformats.org/drawingml/2006/main">
+            <a:pPr/>
             <a:r>
               <a:t>CC-BY</a:t>
             </a:r>
@@ -7174,6 +7393,7 @@
           <a:bodyPr xmlns:a="http://schemas.openxmlformats.org/drawingml/2006/main" wrap="square" lIns="76200" tIns="38100" rIns="76200" bIns="38100" anchor="ctr"/>
           <a:lstStyle xmlns:a="http://schemas.openxmlformats.org/drawingml/2006/main"/>
           <a:p xmlns:a="http://schemas.openxmlformats.org/drawingml/2006/main">
+            <a:pPr/>
             <a:r>
               <a:t>模型输入、实验结果</a:t>
             </a:r>
@@ -7240,6 +7460,7 @@
           <a:bodyPr xmlns:a="http://schemas.openxmlformats.org/drawingml/2006/main" wrap="square" lIns="76200" tIns="38100" rIns="76200" bIns="38100" anchor="ctr"/>
           <a:lstStyle xmlns:a="http://schemas.openxmlformats.org/drawingml/2006/main"/>
           <a:p xmlns:a="http://schemas.openxmlformats.org/drawingml/2006/main">
+            <a:pPr/>
             <a:r>
               <a:t>biocatalysis_case</a:t>
             </a:r>
@@ -7306,6 +7527,7 @@
           <a:bodyPr xmlns:a="http://schemas.openxmlformats.org/drawingml/2006/main" wrap="square" lIns="76200" tIns="38100" rIns="76200" bIns="38100" anchor="ctr"/>
           <a:lstStyle xmlns:a="http://schemas.openxmlformats.org/drawingml/2006/main"/>
           <a:p xmlns:a="http://schemas.openxmlformats.org/drawingml/2006/main">
+            <a:pPr/>
             <a:r>
               <a:t>生物催化</a:t>
             </a:r>
@@ -7372,6 +7594,7 @@
           <a:bodyPr xmlns:a="http://schemas.openxmlformats.org/drawingml/2006/main" wrap="square" lIns="76200" tIns="38100" rIns="76200" bIns="38100" anchor="ctr"/>
           <a:lstStyle xmlns:a="http://schemas.openxmlformats.org/drawingml/2006/main"/>
           <a:p xmlns:a="http://schemas.openxmlformats.org/drawingml/2006/main">
+            <a:pPr/>
             <a:r>
               <a:t>定向进化 + 验证</a:t>
             </a:r>
@@ -7438,6 +7661,7 @@
           <a:bodyPr xmlns:a="http://schemas.openxmlformats.org/drawingml/2006/main" wrap="square" lIns="76200" tIns="38100" rIns="76200" bIns="38100" anchor="ctr"/>
           <a:lstStyle xmlns:a="http://schemas.openxmlformats.org/drawingml/2006/main"/>
           <a:p xmlns:a="http://schemas.openxmlformats.org/drawingml/2006/main">
+            <a:pPr/>
             <a:r>
               <a:t>CC-BY</a:t>
             </a:r>
@@ -7504,6 +7728,7 @@
           <a:bodyPr xmlns:a="http://schemas.openxmlformats.org/drawingml/2006/main" wrap="square" lIns="76200" tIns="38100" rIns="76200" bIns="38100" anchor="ctr"/>
           <a:lstStyle xmlns:a="http://schemas.openxmlformats.org/drawingml/2006/main"/>
           <a:p xmlns:a="http://schemas.openxmlformats.org/drawingml/2006/main">
+            <a:pPr/>
             <a:r>
               <a:t>轮次指标、终点结论</a:t>
             </a:r>
@@ -7570,6 +7795,7 @@
           <a:bodyPr xmlns:a="http://schemas.openxmlformats.org/drawingml/2006/main" wrap="square" lIns="76200" tIns="38100" rIns="76200" bIns="38100" anchor="ctr"/>
           <a:lstStyle xmlns:a="http://schemas.openxmlformats.org/drawingml/2006/main"/>
           <a:p xmlns:a="http://schemas.openxmlformats.org/drawingml/2006/main">
+            <a:pPr/>
             <a:r>
               <a:t>openalex_queue</a:t>
             </a:r>
@@ -7636,6 +7862,7 @@
           <a:bodyPr xmlns:a="http://schemas.openxmlformats.org/drawingml/2006/main" wrap="square" lIns="76200" tIns="38100" rIns="76200" bIns="38100" anchor="ctr"/>
           <a:lstStyle xmlns:a="http://schemas.openxmlformats.org/drawingml/2006/main"/>
           <a:p xmlns:a="http://schemas.openxmlformats.org/drawingml/2006/main">
+            <a:pPr/>
             <a:r>
               <a:t>候选扩展</a:t>
             </a:r>
@@ -7702,6 +7929,7 @@
           <a:bodyPr xmlns:a="http://schemas.openxmlformats.org/drawingml/2006/main" wrap="square" lIns="76200" tIns="38100" rIns="76200" bIns="38100" anchor="ctr"/>
           <a:lstStyle xmlns:a="http://schemas.openxmlformats.org/drawingml/2006/main"/>
           <a:p xmlns:a="http://schemas.openxmlformats.org/drawingml/2006/main">
+            <a:pPr/>
             <a:r>
               <a:t>许可筛选 + 后续解析</a:t>
             </a:r>
@@ -7768,6 +7996,7 @@
           <a:bodyPr xmlns:a="http://schemas.openxmlformats.org/drawingml/2006/main" wrap="square" lIns="76200" tIns="38100" rIns="76200" bIns="38100" anchor="ctr"/>
           <a:lstStyle xmlns:a="http://schemas.openxmlformats.org/drawingml/2006/main"/>
           <a:p xmlns:a="http://schemas.openxmlformats.org/drawingml/2006/main">
+            <a:pPr/>
             <a:r>
               <a:t>14 可处理</a:t>
             </a:r>
@@ -7834,6 +8063,7 @@
           <a:bodyPr xmlns:a="http://schemas.openxmlformats.org/drawingml/2006/main" wrap="square" lIns="76200" tIns="38100" rIns="76200" bIns="38100" anchor="ctr"/>
           <a:lstStyle xmlns:a="http://schemas.openxmlformats.org/drawingml/2006/main"/>
           <a:p xmlns:a="http://schemas.openxmlformats.org/drawingml/2006/main">
+            <a:pPr/>
             <a:r>
               <a:t>DOI、OA 链接、许可状态</a:t>
             </a:r>
@@ -7868,6 +8098,7 @@
           <a:bodyPr xmlns:a="http://schemas.openxmlformats.org/drawingml/2006/main" wrap="square" lIns="76200" tIns="38100" rIns="76200" bIns="38100" anchor="ctr"/>
           <a:lstStyle xmlns:a="http://schemas.openxmlformats.org/drawingml/2006/main"/>
           <a:p xmlns:a="http://schemas.openxmlformats.org/drawingml/2006/main">
+            <a:pPr/>
             <a:r>
               <a:t>这张表让评委可以在一页内看清当前数据覆盖、来源合规性和后续扩展空间。</a:t>
             </a:r>
@@ -7995,8 +8226,9 @@
           <a:bodyPr xmlns:a="http://schemas.openxmlformats.org/drawingml/2006/main" wrap="square" lIns="76200" tIns="38100" rIns="76200" bIns="38100" anchor="ctr"/>
           <a:lstStyle xmlns:a="http://schemas.openxmlformats.org/drawingml/2006/main"/>
           <a:p xmlns:a="http://schemas.openxmlformats.org/drawingml/2006/main">
-            <a:r>
-              <a:t>标注策略</a:t>
+            <a:pPr/>
+            <a:r>
+              <a:t>标注结构</a:t>
             </a:r>
           </a:p>
         </p:txBody>
@@ -8029,8 +8261,9 @@
           <a:bodyPr xmlns:a="http://schemas.openxmlformats.org/drawingml/2006/main" wrap="square" lIns="0" tIns="0" rIns="76200" bIns="0" anchor="ctr"/>
           <a:lstStyle xmlns:a="http://schemas.openxmlformats.org/drawingml/2006/main"/>
           <a:p xmlns:a="http://schemas.openxmlformats.org/drawingml/2006/main">
-            <a:r>
-              <a:t>目标定义不只写摘要，而是决定轨迹边界、验证标准和评测方式。</a:t>
+            <a:pPr/>
+            <a:r>
+              <a:t>每条 case 都按“目标、过程、验证、质量”四层组织。</a:t>
             </a:r>
           </a:p>
         </p:txBody>
@@ -8063,6 +8296,7 @@
           <a:bodyPr xmlns:a="http://schemas.openxmlformats.org/drawingml/2006/main" wrap="square" lIns="76200" tIns="38100" rIns="76200" bIns="38100" anchor="ctr"/>
           <a:lstStyle xmlns:a="http://schemas.openxmlformats.org/drawingml/2006/main"/>
           <a:p xmlns:a="http://schemas.openxmlformats.org/drawingml/2006/main">
+            <a:pPr/>
             <a:r>
               <a:t>Sci-Evo · LabTrace</a:t>
             </a:r>
@@ -8097,6 +8331,7 @@
           <a:bodyPr xmlns:a="http://schemas.openxmlformats.org/drawingml/2006/main" wrap="square" lIns="76200" tIns="38100" rIns="76200" bIns="38100" anchor="ctr"/>
           <a:lstStyle xmlns:a="http://schemas.openxmlformats.org/drawingml/2006/main"/>
           <a:p xmlns:a="http://schemas.openxmlformats.org/drawingml/2006/main">
+            <a:pPr/>
             <a:r>
               <a:t>06</a:t>
             </a:r>
@@ -8163,6 +8398,7 @@
           <a:bodyPr xmlns:a="http://schemas.openxmlformats.org/drawingml/2006/main" wrap="square" lIns="76200" tIns="38100" rIns="76200" bIns="38100" anchor="ctr"/>
           <a:lstStyle xmlns:a="http://schemas.openxmlformats.org/drawingml/2006/main"/>
           <a:p xmlns:a="http://schemas.openxmlformats.org/drawingml/2006/main">
+            <a:pPr/>
             <a:r>
               <a:t>case 画像</a:t>
             </a:r>
@@ -8197,6 +8433,7 @@
           <a:bodyPr xmlns:a="http://schemas.openxmlformats.org/drawingml/2006/main" wrap="square" lIns="76200" tIns="38100" rIns="76200" bIns="38100" anchor="ctr"/>
           <a:lstStyle xmlns:a="http://schemas.openxmlformats.org/drawingml/2006/main"/>
           <a:p xmlns:a="http://schemas.openxmlformats.org/drawingml/2006/main">
+            <a:pPr/>
             <a:r>
               <a:t>目标</a:t>
             </a:r>
@@ -8231,6 +8468,7 @@
           <a:bodyPr xmlns:a="http://schemas.openxmlformats.org/drawingml/2006/main" wrap="square" lIns="0" tIns="57150" rIns="76200" bIns="57150" anchor="ctr"/>
           <a:lstStyle xmlns:a="http://schemas.openxmlformats.org/drawingml/2006/main"/>
           <a:p xmlns:a="http://schemas.openxmlformats.org/drawingml/2006/main">
+            <a:pPr/>
             <a:r>
               <a:t>从论文中抽取可量化科研目标</a:t>
             </a:r>
@@ -8265,6 +8503,7 @@
           <a:bodyPr xmlns:a="http://schemas.openxmlformats.org/drawingml/2006/main" wrap="square" lIns="76200" tIns="38100" rIns="76200" bIns="38100" anchor="ctr"/>
           <a:lstStyle xmlns:a="http://schemas.openxmlformats.org/drawingml/2006/main"/>
           <a:p xmlns:a="http://schemas.openxmlformats.org/drawingml/2006/main">
+            <a:pPr/>
             <a:r>
               <a:t>难点</a:t>
             </a:r>
@@ -8299,6 +8538,7 @@
           <a:bodyPr xmlns:a="http://schemas.openxmlformats.org/drawingml/2006/main" wrap="square" lIns="0" tIns="57150" rIns="76200" bIns="57150" anchor="ctr"/>
           <a:lstStyle xmlns:a="http://schemas.openxmlformats.org/drawingml/2006/main"/>
           <a:p xmlns:a="http://schemas.openxmlformats.org/drawingml/2006/main">
+            <a:pPr/>
             <a:r>
               <a:t>计算设计、湿实验和失败修正需串联</a:t>
             </a:r>
@@ -8333,6 +8573,7 @@
           <a:bodyPr xmlns:a="http://schemas.openxmlformats.org/drawingml/2006/main" wrap="square" lIns="76200" tIns="38100" rIns="76200" bIns="38100" anchor="ctr"/>
           <a:lstStyle xmlns:a="http://schemas.openxmlformats.org/drawingml/2006/main"/>
           <a:p xmlns:a="http://schemas.openxmlformats.org/drawingml/2006/main">
+            <a:pPr/>
             <a:r>
               <a:t>边界</a:t>
             </a:r>
@@ -8367,6 +8608,7 @@
           <a:bodyPr xmlns:a="http://schemas.openxmlformats.org/drawingml/2006/main" wrap="square" lIns="0" tIns="57150" rIns="76200" bIns="57150" anchor="ctr"/>
           <a:lstStyle xmlns:a="http://schemas.openxmlformats.org/drawingml/2006/main"/>
           <a:p xmlns:a="http://schemas.openxmlformats.org/drawingml/2006/main">
+            <a:pPr/>
             <a:r>
               <a:t>只保留有证据和许可状态的步骤</a:t>
             </a:r>
@@ -8401,6 +8643,7 @@
           <a:bodyPr xmlns:a="http://schemas.openxmlformats.org/drawingml/2006/main" wrap="square" lIns="76200" tIns="38100" rIns="76200" bIns="38100" anchor="ctr"/>
           <a:lstStyle xmlns:a="http://schemas.openxmlformats.org/drawingml/2006/main"/>
           <a:p xmlns:a="http://schemas.openxmlformats.org/drawingml/2006/main">
+            <a:pPr/>
             <a:r>
               <a:t>→</a:t>
             </a:r>
@@ -8499,6 +8742,7 @@
           <a:bodyPr xmlns:a="http://schemas.openxmlformats.org/drawingml/2006/main" wrap="square" lIns="76200" tIns="38100" rIns="76200" bIns="38100" anchor="ctr"/>
           <a:lstStyle xmlns:a="http://schemas.openxmlformats.org/drawingml/2006/main"/>
           <a:p xmlns:a="http://schemas.openxmlformats.org/drawingml/2006/main">
+            <a:pPr/>
             <a:r>
               <a:t>进入结构化标注</a:t>
             </a:r>
@@ -8533,6 +8777,7 @@
           <a:bodyPr xmlns:a="http://schemas.openxmlformats.org/drawingml/2006/main" wrap="square" lIns="76200" tIns="38100" rIns="76200" bIns="38100" anchor="ctr"/>
           <a:lstStyle xmlns:a="http://schemas.openxmlformats.org/drawingml/2006/main"/>
           <a:p xmlns:a="http://schemas.openxmlformats.org/drawingml/2006/main">
+            <a:pPr/>
             <a:r>
               <a:t>initial_request</a:t>
             </a:r>
@@ -8567,6 +8812,7 @@
           <a:bodyPr xmlns:a="http://schemas.openxmlformats.org/drawingml/2006/main" wrap="square" lIns="76200" tIns="38100" rIns="76200" bIns="38100" anchor="ctr"/>
           <a:lstStyle xmlns:a="http://schemas.openxmlformats.org/drawingml/2006/main"/>
           <a:p xmlns:a="http://schemas.openxmlformats.org/drawingml/2006/main">
+            <a:pPr/>
             <a:r>
               <a:t>目标、约束、量化指标</a:t>
             </a:r>
@@ -8601,6 +8847,7 @@
           <a:bodyPr xmlns:a="http://schemas.openxmlformats.org/drawingml/2006/main" wrap="square" lIns="76200" tIns="38100" rIns="76200" bIns="38100" anchor="ctr"/>
           <a:lstStyle xmlns:a="http://schemas.openxmlformats.org/drawingml/2006/main"/>
           <a:p xmlns:a="http://schemas.openxmlformats.org/drawingml/2006/main">
+            <a:pPr/>
             <a:r>
               <a:t>agent_trajectory</a:t>
             </a:r>
@@ -8635,6 +8882,7 @@
           <a:bodyPr xmlns:a="http://schemas.openxmlformats.org/drawingml/2006/main" wrap="square" lIns="76200" tIns="38100" rIns="76200" bIns="38100" anchor="ctr"/>
           <a:lstStyle xmlns:a="http://schemas.openxmlformats.org/drawingml/2006/main"/>
           <a:p xmlns:a="http://schemas.openxmlformats.org/drawingml/2006/main">
+            <a:pPr/>
             <a:r>
               <a:t>action / tool / parameter / observation</a:t>
             </a:r>
@@ -8669,6 +8917,7 @@
           <a:bodyPr xmlns:a="http://schemas.openxmlformats.org/drawingml/2006/main" wrap="square" lIns="76200" tIns="38100" rIns="76200" bIns="38100" anchor="ctr"/>
           <a:lstStyle xmlns:a="http://schemas.openxmlformats.org/drawingml/2006/main"/>
           <a:p xmlns:a="http://schemas.openxmlformats.org/drawingml/2006/main">
+            <a:pPr/>
             <a:r>
               <a:t>success_verification</a:t>
             </a:r>
@@ -8703,6 +8952,7 @@
           <a:bodyPr xmlns:a="http://schemas.openxmlformats.org/drawingml/2006/main" wrap="square" lIns="76200" tIns="38100" rIns="76200" bIns="38100" anchor="ctr"/>
           <a:lstStyle xmlns:a="http://schemas.openxmlformats.org/drawingml/2006/main"/>
           <a:p xmlns:a="http://schemas.openxmlformats.org/drawingml/2006/main">
+            <a:pPr/>
             <a:r>
               <a:t>最终验证方法与指标</a:t>
             </a:r>
@@ -8737,6 +8987,7 @@
           <a:bodyPr xmlns:a="http://schemas.openxmlformats.org/drawingml/2006/main" wrap="square" lIns="76200" tIns="38100" rIns="76200" bIns="38100" anchor="ctr"/>
           <a:lstStyle xmlns:a="http://schemas.openxmlformats.org/drawingml/2006/main"/>
           <a:p xmlns:a="http://schemas.openxmlformats.org/drawingml/2006/main">
+            <a:pPr/>
             <a:r>
               <a:t>quality</a:t>
             </a:r>
@@ -8771,6 +9022,7 @@
           <a:bodyPr xmlns:a="http://schemas.openxmlformats.org/drawingml/2006/main" wrap="square" lIns="76200" tIns="38100" rIns="76200" bIns="38100" anchor="ctr"/>
           <a:lstStyle xmlns:a="http://schemas.openxmlformats.org/drawingml/2006/main"/>
           <a:p xmlns:a="http://schemas.openxmlformats.org/drawingml/2006/main">
+            <a:pPr/>
             <a:r>
               <a:t>gold 等级、证据覆盖、许可复核</a:t>
             </a:r>
@@ -8805,6 +9057,7 @@
           <a:bodyPr xmlns:a="http://schemas.openxmlformats.org/drawingml/2006/main" wrap="square" lIns="76200" tIns="38100" rIns="76200" bIns="38100" anchor="ctr"/>
           <a:lstStyle xmlns:a="http://schemas.openxmlformats.org/drawingml/2006/main"/>
           <a:p xmlns:a="http://schemas.openxmlformats.org/drawingml/2006/main">
+            <a:pPr/>
             <a:r>
               <a:t>同一篇论文的切分方式会直接影响样本质量；我们的原则是先定边界，再抽步骤，再做证据绑定。</a:t>
             </a:r>
@@ -8932,6 +9185,7 @@
           <a:bodyPr xmlns:a="http://schemas.openxmlformats.org/drawingml/2006/main" wrap="square" lIns="76200" tIns="38100" rIns="76200" bIns="38100" anchor="ctr"/>
           <a:lstStyle xmlns:a="http://schemas.openxmlformats.org/drawingml/2006/main"/>
           <a:p xmlns:a="http://schemas.openxmlformats.org/drawingml/2006/main">
+            <a:pPr/>
             <a:r>
               <a:t>工程体系</a:t>
             </a:r>
@@ -8966,8 +9220,9 @@
           <a:bodyPr xmlns:a="http://schemas.openxmlformats.org/drawingml/2006/main" wrap="square" lIns="0" tIns="0" rIns="76200" bIns="0" anchor="ctr"/>
           <a:lstStyle xmlns:a="http://schemas.openxmlformats.org/drawingml/2006/main"/>
           <a:p xmlns:a="http://schemas.openxmlformats.org/drawingml/2006/main">
-            <a:r>
-              <a:t>数据、报告、脚本和说明材料需要放在同一个清晰结构里。</a:t>
+            <a:pPr/>
+            <a:r>
+              <a:t>评委从项目目录就能进入数据、报告、脚本和证据。</a:t>
             </a:r>
           </a:p>
         </p:txBody>
@@ -9000,6 +9255,7 @@
           <a:bodyPr xmlns:a="http://schemas.openxmlformats.org/drawingml/2006/main" wrap="square" lIns="76200" tIns="38100" rIns="76200" bIns="38100" anchor="ctr"/>
           <a:lstStyle xmlns:a="http://schemas.openxmlformats.org/drawingml/2006/main"/>
           <a:p xmlns:a="http://schemas.openxmlformats.org/drawingml/2006/main">
+            <a:pPr/>
             <a:r>
               <a:t>Sci-Evo · LabTrace</a:t>
             </a:r>
@@ -9034,6 +9290,7 @@
           <a:bodyPr xmlns:a="http://schemas.openxmlformats.org/drawingml/2006/main" wrap="square" lIns="76200" tIns="38100" rIns="76200" bIns="38100" anchor="ctr"/>
           <a:lstStyle xmlns:a="http://schemas.openxmlformats.org/drawingml/2006/main"/>
           <a:p xmlns:a="http://schemas.openxmlformats.org/drawingml/2006/main">
+            <a:pPr/>
             <a:r>
               <a:t>07</a:t>
             </a:r>
@@ -9100,7 +9357,13 @@
           <a:bodyPr xmlns:a="http://schemas.openxmlformats.org/drawingml/2006/main" wrap="square" lIns="76200" tIns="38100" rIns="76200" bIns="38100" anchor="ctr"/>
           <a:lstStyle xmlns:a="http://schemas.openxmlformats.org/drawingml/2006/main"/>
           <a:p xmlns:a="http://schemas.openxmlformats.org/drawingml/2006/main">
-            <a:r>
+            <a:pPr/>
+            <a:r>
+              <a:rPr>
+                <a:solidFill>
+                  <a:srgbClr val="F8FAFC"/>
+                </a:solidFill>
+              </a:rPr>
               <a:t>项目目录</a:t>
             </a:r>
           </a:p>
@@ -9134,8 +9397,14 @@
           <a:bodyPr xmlns:a="http://schemas.openxmlformats.org/drawingml/2006/main" wrap="square" lIns="76200" tIns="38100" rIns="76200" bIns="38100" anchor="ctr"/>
           <a:lstStyle xmlns:a="http://schemas.openxmlformats.org/drawingml/2006/main"/>
           <a:p xmlns:a="http://schemas.openxmlformats.org/drawingml/2006/main">
-            <a:r>
-              <a:t>数据、文档、报告与脚本按统一结构组织</a:t>
+            <a:pPr/>
+            <a:r>
+              <a:rPr>
+                <a:solidFill>
+                  <a:srgbClr val="E5E7EB"/>
+                </a:solidFill>
+              </a:rPr>
+              <a:t>数据 / 文档 / 报告 / 脚本</a:t>
             </a:r>
           </a:p>
         </p:txBody>
@@ -9200,6 +9469,7 @@
           <a:bodyPr xmlns:a="http://schemas.openxmlformats.org/drawingml/2006/main" wrap="square" lIns="76200" tIns="38100" rIns="76200" bIns="38100" anchor="ctr"/>
           <a:lstStyle xmlns:a="http://schemas.openxmlformats.org/drawingml/2006/main"/>
           <a:p xmlns:a="http://schemas.openxmlformats.org/drawingml/2006/main">
+            <a:pPr/>
             <a:r>
               <a:t>数据</a:t>
             </a:r>
@@ -9234,8 +9504,9 @@
           <a:bodyPr xmlns:a="http://schemas.openxmlformats.org/drawingml/2006/main" wrap="square" lIns="76200" tIns="38100" rIns="76200" bIns="38100" anchor="ctr"/>
           <a:lstStyle xmlns:a="http://schemas.openxmlformats.org/drawingml/2006/main"/>
           <a:p xmlns:a="http://schemas.openxmlformats.org/drawingml/2006/main">
-            <a:r>
-              <a:t>scievo_gold.jsonl / scievo_eval_tasks.jsonl</a:t>
+            <a:pPr/>
+            <a:r>
+              <a:t>Gold JSONL / Eval tasks</a:t>
             </a:r>
           </a:p>
         </p:txBody>
@@ -9300,6 +9571,7 @@
           <a:bodyPr xmlns:a="http://schemas.openxmlformats.org/drawingml/2006/main" wrap="square" lIns="76200" tIns="38100" rIns="76200" bIns="38100" anchor="ctr"/>
           <a:lstStyle xmlns:a="http://schemas.openxmlformats.org/drawingml/2006/main"/>
           <a:p xmlns:a="http://schemas.openxmlformats.org/drawingml/2006/main">
+            <a:pPr/>
             <a:r>
               <a:t>文档</a:t>
             </a:r>
@@ -9334,8 +9606,9 @@
           <a:bodyPr xmlns:a="http://schemas.openxmlformats.org/drawingml/2006/main" wrap="square" lIns="76200" tIns="38100" rIns="76200" bIns="38100" anchor="ctr"/>
           <a:lstStyle xmlns:a="http://schemas.openxmlformats.org/drawingml/2006/main"/>
           <a:p xmlns:a="http://schemas.openxmlformats.org/drawingml/2006/main">
-            <a:r>
-              <a:t>README.md / TECHNICAL_REPORT.md</a:t>
+            <a:pPr/>
+            <a:r>
+              <a:t>README / 技术报告</a:t>
             </a:r>
           </a:p>
         </p:txBody>
@@ -9400,6 +9673,7 @@
           <a:bodyPr xmlns:a="http://schemas.openxmlformats.org/drawingml/2006/main" wrap="square" lIns="76200" tIns="38100" rIns="76200" bIns="38100" anchor="ctr"/>
           <a:lstStyle xmlns:a="http://schemas.openxmlformats.org/drawingml/2006/main"/>
           <a:p xmlns:a="http://schemas.openxmlformats.org/drawingml/2006/main">
+            <a:pPr/>
             <a:r>
               <a:t>报告</a:t>
             </a:r>
@@ -9434,8 +9708,9 @@
           <a:bodyPr xmlns:a="http://schemas.openxmlformats.org/drawingml/2006/main" wrap="square" lIns="76200" tIns="38100" rIns="76200" bIns="38100" anchor="ctr"/>
           <a:lstStyle xmlns:a="http://schemas.openxmlformats.org/drawingml/2006/main"/>
           <a:p xmlns:a="http://schemas.openxmlformats.org/drawingml/2006/main">
-            <a:r>
-              <a:t>QUALITY_REPORT.md / MINERU_RUN_REPORT.md</a:t>
+            <a:pPr/>
+            <a:r>
+              <a:t>质量报告 / MinerU 报告</a:t>
             </a:r>
           </a:p>
         </p:txBody>
@@ -9500,6 +9775,7 @@
           <a:bodyPr xmlns:a="http://schemas.openxmlformats.org/drawingml/2006/main" wrap="square" lIns="76200" tIns="38100" rIns="76200" bIns="38100" anchor="ctr"/>
           <a:lstStyle xmlns:a="http://schemas.openxmlformats.org/drawingml/2006/main"/>
           <a:p xmlns:a="http://schemas.openxmlformats.org/drawingml/2006/main">
+            <a:pPr/>
             <a:r>
               <a:t>工具</a:t>
             </a:r>
@@ -9534,8 +9810,9 @@
           <a:bodyPr xmlns:a="http://schemas.openxmlformats.org/drawingml/2006/main" wrap="square" lIns="76200" tIns="38100" rIns="76200" bIns="38100" anchor="ctr"/>
           <a:lstStyle xmlns:a="http://schemas.openxmlformats.org/drawingml/2006/main"/>
           <a:p xmlns:a="http://schemas.openxmlformats.org/drawingml/2006/main">
-            <a:r>
-              <a:t>build_dataset.py / validate_dataset.py</a:t>
+            <a:pPr/>
+            <a:r>
+              <a:t>build / validate</a:t>
             </a:r>
           </a:p>
         </p:txBody>
@@ -9824,6 +10101,7 @@
           <a:bodyPr xmlns:a="http://schemas.openxmlformats.org/drawingml/2006/main" wrap="square" lIns="0" tIns="57150" rIns="76200" bIns="57150" anchor="ctr"/>
           <a:lstStyle xmlns:a="http://schemas.openxmlformats.org/drawingml/2006/main"/>
           <a:p xmlns:a="http://schemas.openxmlformats.org/drawingml/2006/main">
+            <a:pPr/>
             <a:r>
               <a:t>核心材料彼此可互相印证：数据能被脚本校验，报告能回到来源与指标。</a:t>
             </a:r>
@@ -9951,8 +10229,9 @@
           <a:bodyPr xmlns:a="http://schemas.openxmlformats.org/drawingml/2006/main" wrap="square" lIns="76200" tIns="38100" rIns="76200" bIns="38100" anchor="ctr"/>
           <a:lstStyle xmlns:a="http://schemas.openxmlformats.org/drawingml/2006/main"/>
           <a:p xmlns:a="http://schemas.openxmlformats.org/drawingml/2006/main">
-            <a:r>
-              <a:t>质量闭环</a:t>
+            <a:pPr/>
+            <a:r>
+              <a:t>质量验证</a:t>
             </a:r>
           </a:p>
         </p:txBody>
@@ -9985,8 +10264,9 @@
           <a:bodyPr xmlns:a="http://schemas.openxmlformats.org/drawingml/2006/main" wrap="square" lIns="0" tIns="0" rIns="76200" bIns="0" anchor="ctr"/>
           <a:lstStyle xmlns:a="http://schemas.openxmlformats.org/drawingml/2006/main"/>
           <a:p xmlns:a="http://schemas.openxmlformats.org/drawingml/2006/main">
-            <a:r>
-              <a:t>每个 case 通过结构校验后，还要被证据、许可和评测任务反向约束。</a:t>
+            <a:pPr/>
+            <a:r>
+              <a:t>质量不是口头承诺，而是由校验脚本、评测任务和报告共同约束。</a:t>
             </a:r>
           </a:p>
         </p:txBody>
@@ -10019,6 +10299,7 @@
           <a:bodyPr xmlns:a="http://schemas.openxmlformats.org/drawingml/2006/main" wrap="square" lIns="76200" tIns="38100" rIns="76200" bIns="38100" anchor="ctr"/>
           <a:lstStyle xmlns:a="http://schemas.openxmlformats.org/drawingml/2006/main"/>
           <a:p xmlns:a="http://schemas.openxmlformats.org/drawingml/2006/main">
+            <a:pPr/>
             <a:r>
               <a:t>Sci-Evo · LabTrace</a:t>
             </a:r>
@@ -10053,6 +10334,7 @@
           <a:bodyPr xmlns:a="http://schemas.openxmlformats.org/drawingml/2006/main" wrap="square" lIns="76200" tIns="38100" rIns="76200" bIns="38100" anchor="ctr"/>
           <a:lstStyle xmlns:a="http://schemas.openxmlformats.org/drawingml/2006/main"/>
           <a:p xmlns:a="http://schemas.openxmlformats.org/drawingml/2006/main">
+            <a:pPr/>
             <a:r>
               <a:t>08</a:t>
             </a:r>
@@ -10119,6 +10401,7 @@
           <a:bodyPr xmlns:a="http://schemas.openxmlformats.org/drawingml/2006/main" wrap="square" lIns="0" tIns="0" rIns="0" bIns="0" anchor="ctr"/>
           <a:lstStyle xmlns:a="http://schemas.openxmlformats.org/drawingml/2006/main"/>
           <a:p xmlns:a="http://schemas.openxmlformats.org/drawingml/2006/main">
+            <a:pPr/>
             <a:r>
               <a:t>3/3</a:t>
             </a:r>
@@ -10153,6 +10436,7 @@
           <a:bodyPr xmlns:a="http://schemas.openxmlformats.org/drawingml/2006/main" wrap="square" lIns="0" tIns="0" rIns="0" bIns="0" anchor="ctr"/>
           <a:lstStyle xmlns:a="http://schemas.openxmlformats.org/drawingml/2006/main"/>
           <a:p xmlns:a="http://schemas.openxmlformats.org/drawingml/2006/main">
+            <a:pPr/>
             <a:r>
               <a:t>Gold case 通过校验</a:t>
             </a:r>
@@ -10219,6 +10503,7 @@
           <a:bodyPr xmlns:a="http://schemas.openxmlformats.org/drawingml/2006/main" wrap="square" lIns="0" tIns="0" rIns="0" bIns="0" anchor="ctr"/>
           <a:lstStyle xmlns:a="http://schemas.openxmlformats.org/drawingml/2006/main"/>
           <a:p xmlns:a="http://schemas.openxmlformats.org/drawingml/2006/main">
+            <a:pPr/>
             <a:r>
               <a:t>37</a:t>
             </a:r>
@@ -10253,6 +10538,7 @@
           <a:bodyPr xmlns:a="http://schemas.openxmlformats.org/drawingml/2006/main" wrap="square" lIns="0" tIns="0" rIns="0" bIns="0" anchor="ctr"/>
           <a:lstStyle xmlns:a="http://schemas.openxmlformats.org/drawingml/2006/main"/>
           <a:p xmlns:a="http://schemas.openxmlformats.org/drawingml/2006/main">
+            <a:pPr/>
             <a:r>
               <a:t>自动评测任务</a:t>
             </a:r>
@@ -10319,6 +10605,7 @@
           <a:bodyPr xmlns:a="http://schemas.openxmlformats.org/drawingml/2006/main" wrap="square" lIns="0" tIns="0" rIns="0" bIns="0" anchor="ctr"/>
           <a:lstStyle xmlns:a="http://schemas.openxmlformats.org/drawingml/2006/main"/>
           <a:p xmlns:a="http://schemas.openxmlformats.org/drawingml/2006/main">
+            <a:pPr/>
             <a:r>
               <a:t>25</a:t>
             </a:r>
@@ -10353,6 +10640,7 @@
           <a:bodyPr xmlns:a="http://schemas.openxmlformats.org/drawingml/2006/main" wrap="square" lIns="0" tIns="0" rIns="0" bIns="0" anchor="ctr"/>
           <a:lstStyle xmlns:a="http://schemas.openxmlformats.org/drawingml/2006/main"/>
           <a:p xmlns:a="http://schemas.openxmlformats.org/drawingml/2006/main">
+            <a:pPr/>
             <a:r>
               <a:t>开放来源已筛选</a:t>
             </a:r>
@@ -10419,6 +10707,7 @@
           <a:bodyPr xmlns:a="http://schemas.openxmlformats.org/drawingml/2006/main" wrap="square" lIns="0" tIns="0" rIns="0" bIns="0" anchor="ctr"/>
           <a:lstStyle xmlns:a="http://schemas.openxmlformats.org/drawingml/2006/main"/>
           <a:p xmlns:a="http://schemas.openxmlformats.org/drawingml/2006/main">
+            <a:pPr/>
             <a:r>
               <a:t>100%</a:t>
             </a:r>
@@ -10453,6 +10742,7 @@
           <a:bodyPr xmlns:a="http://schemas.openxmlformats.org/drawingml/2006/main" wrap="square" lIns="0" tIns="0" rIns="0" bIns="0" anchor="ctr"/>
           <a:lstStyle xmlns:a="http://schemas.openxmlformats.org/drawingml/2006/main"/>
           <a:p xmlns:a="http://schemas.openxmlformats.org/drawingml/2006/main">
+            <a:pPr/>
             <a:r>
               <a:t>核心材料完备</a:t>
             </a:r>
@@ -10519,6 +10809,7 @@
           <a:bodyPr xmlns:a="http://schemas.openxmlformats.org/drawingml/2006/main" wrap="square" lIns="76200" tIns="38100" rIns="76200" bIns="38100" anchor="ctr"/>
           <a:lstStyle xmlns:a="http://schemas.openxmlformats.org/drawingml/2006/main"/>
           <a:p xmlns:a="http://schemas.openxmlformats.org/drawingml/2006/main">
+            <a:pPr/>
             <a:r>
               <a:t>许可状态</a:t>
             </a:r>
@@ -10553,6 +10844,7 @@
           <a:bodyPr xmlns:a="http://schemas.openxmlformats.org/drawingml/2006/main" wrap="square" lIns="76200" tIns="38100" rIns="76200" bIns="38100" anchor="ctr"/>
           <a:lstStyle xmlns:a="http://schemas.openxmlformats.org/drawingml/2006/main"/>
           <a:p xmlns:a="http://schemas.openxmlformats.org/drawingml/2006/main">
+            <a:pPr/>
             <a:r>
               <a:t>CC-BY 2 / 样例待复核 1</a:t>
             </a:r>
@@ -10619,6 +10911,7 @@
           <a:bodyPr xmlns:a="http://schemas.openxmlformats.org/drawingml/2006/main" wrap="square" lIns="76200" tIns="38100" rIns="76200" bIns="38100" anchor="ctr"/>
           <a:lstStyle xmlns:a="http://schemas.openxmlformats.org/drawingml/2006/main"/>
           <a:p xmlns:a="http://schemas.openxmlformats.org/drawingml/2006/main">
+            <a:pPr/>
             <a:r>
               <a:t>质量报告</a:t>
             </a:r>
@@ -10653,6 +10946,7 @@
           <a:bodyPr xmlns:a="http://schemas.openxmlformats.org/drawingml/2006/main" wrap="square" lIns="76200" tIns="38100" rIns="76200" bIns="38100" anchor="ctr"/>
           <a:lstStyle xmlns:a="http://schemas.openxmlformats.org/drawingml/2006/main"/>
           <a:p xmlns:a="http://schemas.openxmlformats.org/drawingml/2006/main">
+            <a:pPr/>
             <a:r>
               <a:t>已生成</a:t>
             </a:r>
@@ -10719,6 +11013,7 @@
           <a:bodyPr xmlns:a="http://schemas.openxmlformats.org/drawingml/2006/main" wrap="square" lIns="76200" tIns="38100" rIns="76200" bIns="38100" anchor="ctr"/>
           <a:lstStyle xmlns:a="http://schemas.openxmlformats.org/drawingml/2006/main"/>
           <a:p xmlns:a="http://schemas.openxmlformats.org/drawingml/2006/main">
+            <a:pPr/>
             <a:r>
               <a:t>一致性检查</a:t>
             </a:r>
@@ -10753,6 +11048,7 @@
           <a:bodyPr xmlns:a="http://schemas.openxmlformats.org/drawingml/2006/main" wrap="square" lIns="76200" tIns="38100" rIns="76200" bIns="38100" anchor="ctr"/>
           <a:lstStyle xmlns:a="http://schemas.openxmlformats.org/drawingml/2006/main"/>
           <a:p xmlns:a="http://schemas.openxmlformats.org/drawingml/2006/main">
+            <a:pPr/>
             <a:r>
               <a:t>通过</a:t>
             </a:r>
@@ -10819,6 +11115,7 @@
           <a:bodyPr xmlns:a="http://schemas.openxmlformats.org/drawingml/2006/main" wrap="square" lIns="76200" tIns="38100" rIns="76200" bIns="38100" anchor="ctr"/>
           <a:lstStyle xmlns:a="http://schemas.openxmlformats.org/drawingml/2006/main"/>
           <a:p xmlns:a="http://schemas.openxmlformats.org/drawingml/2006/main">
+            <a:pPr/>
             <a:r>
               <a:t>自动审校</a:t>
             </a:r>
@@ -10885,6 +11182,7 @@
           <a:bodyPr xmlns:a="http://schemas.openxmlformats.org/drawingml/2006/main" wrap="square" lIns="76200" tIns="38100" rIns="76200" bIns="38100" anchor="ctr"/>
           <a:lstStyle xmlns:a="http://schemas.openxmlformats.org/drawingml/2006/main"/>
           <a:p xmlns:a="http://schemas.openxmlformats.org/drawingml/2006/main">
+            <a:pPr/>
             <a:r>
               <a:t>结构校验通过；一致性检查通过。</a:t>
             </a:r>
@@ -10936,10 +11234,8 @@
                   <a:srgbClr val="172033"/>
                 </a:solidFill>
                 <a:latin typeface="Arial"/>
-                <a:ea typeface="Arial"/>
-                <a:cs typeface="Arial"/>
               </a:rPr>
-              <a:t>98/100，DeepSeek ok；题型烟测 96/100，比例偏差 ±1。</a:t>
+              <a:t>校验覆盖：数据结构、评测任务、质量报告、许可状态与 Git 状态。</a:t>
             </a:r>
           </a:p>
         </p:txBody>
@@ -11065,8 +11361,9 @@
           <a:bodyPr xmlns:a="http://schemas.openxmlformats.org/drawingml/2006/main" wrap="square" lIns="76200" tIns="38100" rIns="76200" bIns="38100" anchor="ctr"/>
           <a:lstStyle xmlns:a="http://schemas.openxmlformats.org/drawingml/2006/main"/>
           <a:p xmlns:a="http://schemas.openxmlformats.org/drawingml/2006/main">
-            <a:r>
-              <a:t>项目概览</a:t>
+            <a:pPr/>
+            <a:r>
+              <a:t>快速复核</a:t>
             </a:r>
           </a:p>
         </p:txBody>
@@ -11099,8 +11396,9 @@
           <a:bodyPr xmlns:a="http://schemas.openxmlformats.org/drawingml/2006/main" wrap="square" lIns="0" tIns="0" rIns="76200" bIns="0" anchor="ctr"/>
           <a:lstStyle xmlns:a="http://schemas.openxmlformats.org/drawingml/2006/main"/>
           <a:p xmlns:a="http://schemas.openxmlformats.org/drawingml/2006/main">
-            <a:r>
-              <a:t>先看核心事实，再顺着材料路径进入证据与代码。</a:t>
+            <a:pPr/>
+            <a:r>
+              <a:t>先看核心事实，再沿着文件路径进入证据、报告和代码。</a:t>
             </a:r>
           </a:p>
         </p:txBody>
@@ -11133,6 +11431,7 @@
           <a:bodyPr xmlns:a="http://schemas.openxmlformats.org/drawingml/2006/main" wrap="square" lIns="76200" tIns="38100" rIns="76200" bIns="38100" anchor="ctr"/>
           <a:lstStyle xmlns:a="http://schemas.openxmlformats.org/drawingml/2006/main"/>
           <a:p xmlns:a="http://schemas.openxmlformats.org/drawingml/2006/main">
+            <a:pPr/>
             <a:r>
               <a:t>Sci-Evo · LabTrace</a:t>
             </a:r>
@@ -11167,6 +11466,7 @@
           <a:bodyPr xmlns:a="http://schemas.openxmlformats.org/drawingml/2006/main" wrap="square" lIns="76200" tIns="38100" rIns="76200" bIns="38100" anchor="ctr"/>
           <a:lstStyle xmlns:a="http://schemas.openxmlformats.org/drawingml/2006/main"/>
           <a:p xmlns:a="http://schemas.openxmlformats.org/drawingml/2006/main">
+            <a:pPr/>
             <a:r>
               <a:t>09</a:t>
             </a:r>
@@ -11265,7 +11565,13 @@
           <a:bodyPr xmlns:a="http://schemas.openxmlformats.org/drawingml/2006/main" wrap="square" lIns="76200" tIns="38100" rIns="76200" bIns="38100" anchor="ctr"/>
           <a:lstStyle xmlns:a="http://schemas.openxmlformats.org/drawingml/2006/main"/>
           <a:p xmlns:a="http://schemas.openxmlformats.org/drawingml/2006/main">
-            <a:r>
+            <a:pPr/>
+            <a:r>
+              <a:rPr>
+                <a:solidFill>
+                  <a:srgbClr val="F8FAFC"/>
+                </a:solidFill>
+              </a:rPr>
               <a:t>首屏讲清楚三件事</a:t>
             </a:r>
           </a:p>
@@ -11299,8 +11605,14 @@
           <a:bodyPr xmlns:a="http://schemas.openxmlformats.org/drawingml/2006/main" wrap="square" lIns="76200" tIns="38100" rIns="76200" bIns="38100" anchor="ctr"/>
           <a:lstStyle xmlns:a="http://schemas.openxmlformats.org/drawingml/2006/main"/>
           <a:p xmlns:a="http://schemas.openxmlformats.org/drawingml/2006/main">
-            <a:r>
-              <a:t>数据文件</a:t>
+            <a:pPr/>
+            <a:r>
+              <a:rPr>
+                <a:solidFill>
+                  <a:srgbClr val="CBD5E1"/>
+                </a:solidFill>
+              </a:rPr>
+              <a:t>数据</a:t>
             </a:r>
           </a:p>
         </p:txBody>
@@ -11333,7 +11645,13 @@
           <a:bodyPr xmlns:a="http://schemas.openxmlformats.org/drawingml/2006/main" wrap="square" lIns="76200" tIns="38100" rIns="76200" bIns="38100" anchor="ctr"/>
           <a:lstStyle xmlns:a="http://schemas.openxmlformats.org/drawingml/2006/main"/>
           <a:p xmlns:a="http://schemas.openxmlformats.org/drawingml/2006/main">
-            <a:r>
+            <a:pPr/>
+            <a:r>
+              <a:rPr>
+                <a:solidFill>
+                  <a:srgbClr val="F8FAFC"/>
+                </a:solidFill>
+              </a:rPr>
               <a:t>gold / eval / manifest</a:t>
             </a:r>
           </a:p>
@@ -11367,8 +11685,14 @@
           <a:bodyPr xmlns:a="http://schemas.openxmlformats.org/drawingml/2006/main" wrap="square" lIns="76200" tIns="38100" rIns="76200" bIns="38100" anchor="ctr"/>
           <a:lstStyle xmlns:a="http://schemas.openxmlformats.org/drawingml/2006/main"/>
           <a:p xmlns:a="http://schemas.openxmlformats.org/drawingml/2006/main">
-            <a:r>
-              <a:t>关键文档</a:t>
+            <a:pPr/>
+            <a:r>
+              <a:rPr>
+                <a:solidFill>
+                  <a:srgbClr val="CBD5E1"/>
+                </a:solidFill>
+              </a:rPr>
+              <a:t>文档</a:t>
             </a:r>
           </a:p>
         </p:txBody>
@@ -11401,8 +11725,14 @@
           <a:bodyPr xmlns:a="http://schemas.openxmlformats.org/drawingml/2006/main" wrap="square" lIns="76200" tIns="38100" rIns="76200" bIns="38100" anchor="ctr"/>
           <a:lstStyle xmlns:a="http://schemas.openxmlformats.org/drawingml/2006/main"/>
           <a:p xmlns:a="http://schemas.openxmlformats.org/drawingml/2006/main">
-            <a:r>
-              <a:t>README / 技术报告 / 清单</a:t>
+            <a:pPr/>
+            <a:r>
+              <a:rPr>
+                <a:solidFill>
+                  <a:srgbClr val="F8FAFC"/>
+                </a:solidFill>
+              </a:rPr>
+              <a:t>README / 技术报告</a:t>
             </a:r>
           </a:p>
         </p:txBody>
@@ -11435,8 +11765,14 @@
           <a:bodyPr xmlns:a="http://schemas.openxmlformats.org/drawingml/2006/main" wrap="square" lIns="76200" tIns="38100" rIns="76200" bIns="38100" anchor="ctr"/>
           <a:lstStyle xmlns:a="http://schemas.openxmlformats.org/drawingml/2006/main"/>
           <a:p xmlns:a="http://schemas.openxmlformats.org/drawingml/2006/main">
-            <a:r>
-              <a:t>验证结果</a:t>
+            <a:pPr/>
+            <a:r>
+              <a:rPr>
+                <a:solidFill>
+                  <a:srgbClr val="CBD5E1"/>
+                </a:solidFill>
+              </a:rPr>
+              <a:t>验证</a:t>
             </a:r>
           </a:p>
         </p:txBody>
@@ -11469,8 +11805,14 @@
           <a:bodyPr xmlns:a="http://schemas.openxmlformats.org/drawingml/2006/main" wrap="square" lIns="76200" tIns="38100" rIns="76200" bIns="38100" anchor="ctr"/>
           <a:lstStyle xmlns:a="http://schemas.openxmlformats.org/drawingml/2006/main"/>
           <a:p xmlns:a="http://schemas.openxmlformats.org/drawingml/2006/main">
-            <a:r>
-              <a:t>校验通过 / 工作区干净</a:t>
+            <a:pPr/>
+            <a:r>
+              <a:rPr>
+                <a:solidFill>
+                  <a:srgbClr val="F8FAFC"/>
+                </a:solidFill>
+              </a:rPr>
+              <a:t>校验通过</a:t>
             </a:r>
           </a:p>
         </p:txBody>
@@ -11503,8 +11845,14 @@
           <a:bodyPr xmlns:a="http://schemas.openxmlformats.org/drawingml/2006/main" wrap="square" lIns="76200" tIns="38100" rIns="76200" bIns="38100" anchor="ctr"/>
           <a:lstStyle xmlns:a="http://schemas.openxmlformats.org/drawingml/2006/main"/>
           <a:p xmlns:a="http://schemas.openxmlformats.org/drawingml/2006/main">
-            <a:r>
-              <a:t>许可边界</a:t>
+            <a:pPr/>
+            <a:r>
+              <a:rPr>
+                <a:solidFill>
+                  <a:srgbClr val="CBD5E1"/>
+                </a:solidFill>
+              </a:rPr>
+              <a:t>边界</a:t>
             </a:r>
           </a:p>
         </p:txBody>
@@ -11537,15 +11885,21 @@
           <a:bodyPr xmlns:a="http://schemas.openxmlformats.org/drawingml/2006/main" wrap="square" lIns="76200" tIns="38100" rIns="76200" bIns="38100" anchor="ctr"/>
           <a:lstStyle xmlns:a="http://schemas.openxmlformats.org/drawingml/2006/main"/>
           <a:p xmlns:a="http://schemas.openxmlformats.org/drawingml/2006/main">
-            <a:r>
-              <a:t>公开发布前复核全文级产物</a:t>
+            <a:pPr/>
+            <a:r>
+              <a:rPr>
+                <a:solidFill>
+                  <a:srgbClr val="F8FAFC"/>
+                </a:solidFill>
+              </a:rPr>
+              <a:t>许可复核说明</a:t>
             </a:r>
           </a:p>
         </p:txBody>
       </p:sp>
       <p:pic xmlns:a="http://schemas.openxmlformats.org/drawingml/2006/main" xmlns:r="http://schemas.openxmlformats.org/officeDocument/2006/relationships">
         <p:nvPicPr>
-          <p:cNvPr id="19" name="Picture 18" descr="review_materials_overview.png"/>
+          <p:cNvPr id="19" name="Picture 18" descr="image.png"/>
           <p:cNvPicPr>
             <a:picLocks noChangeAspect="1"/>
           </p:cNvPicPr>

</xml_diff>

<commit_message>
Refresh submission package for five-case dataset
</commit_message>
<xml_diff>
--- a/outputs/submission_pack/deliverables/scievo_labtrace_overview.pptx
+++ b/outputs/submission_pack/deliverables/scievo_labtrace_overview.pptx
@@ -1727,7 +1727,7 @@
           <a:p xmlns:a="http://schemas.openxmlformats.org/drawingml/2006/main">
             <a:pPr/>
             <a:r>
-              <a:t>3</a:t>
+              <a:t>5</a:t>
             </a:r>
           </a:p>
         </p:txBody>
@@ -1829,7 +1829,7 @@
           <a:p xmlns:a="http://schemas.openxmlformats.org/drawingml/2006/main">
             <a:pPr/>
             <a:r>
-              <a:t>17</a:t>
+              <a:t>29</a:t>
             </a:r>
           </a:p>
         </p:txBody>
@@ -1931,7 +1931,7 @@
           <a:p xmlns:a="http://schemas.openxmlformats.org/drawingml/2006/main">
             <a:pPr/>
             <a:r>
-              <a:t>37</a:t>
+              <a:t>63</a:t>
             </a:r>
           </a:p>
         </p:txBody>
@@ -2503,7 +2503,7 @@
                   <a:srgbClr val="E5E7EB"/>
                 </a:solidFill>
               </a:rPr>
-              <a:t>基础版本已经完整；后续增强集中在规模、MinerU 覆盖和许可清晰度。</a:t>
+              <a:t>基础版本已经完整；后续增强集中在强 case 密度、录屏和许可清晰度。</a:t>
             </a:r>
           </a:p>
         </p:txBody>
@@ -2847,7 +2847,7 @@
                   <a:srgbClr val="F8FAFC"/>
                 </a:solidFill>
               </a:rPr>
-              <a:t>扩展更多 OA case</a:t>
+              <a:t>扩展更多强闭环 case</a:t>
             </a:r>
           </a:p>
         </p:txBody>
@@ -2887,7 +2887,7 @@
                   <a:srgbClr val="CBD5E1"/>
                 </a:solidFill>
               </a:rPr>
-              <a:t>优先处理 14 条 permitted_for_local_processing 候选。</a:t>
+              <a:t>优先补 3-5 条同主题高证据案例。</a:t>
             </a:r>
           </a:p>
         </p:txBody>
@@ -5842,7 +5842,7 @@
           <a:p xmlns:a="http://schemas.openxmlformats.org/drawingml/2006/main">
             <a:pPr/>
             <a:r>
-              <a:t>样例 PDF</a:t>
+              <a:t>5 个 PDF</a:t>
             </a:r>
           </a:p>
         </p:txBody>
@@ -6320,7 +6320,7 @@
           <a:p xmlns:a="http://schemas.openxmlformats.org/drawingml/2006/main">
             <a:pPr/>
             <a:r>
-              <a:t>当前 3 条 gold case 覆盖样例、开放论文和后续候选队列。</a:t>
+              <a:t>当前 5 条 gold case 覆盖样例、开放论文和后续候选队列。</a:t>
             </a:r>
           </a:p>
         </p:txBody>
@@ -6792,7 +6792,7 @@
           <a:p xmlns:a="http://schemas.openxmlformats.org/drawingml/2006/main">
             <a:pPr/>
             <a:r>
-              <a:t>de_novo_luciferase</a:t>
+              <a:t>0001 luciferase</a:t>
             </a:r>
           </a:p>
         </p:txBody>
@@ -7127,7 +7127,7 @@
           <a:p xmlns:a="http://schemas.openxmlformats.org/drawingml/2006/main">
             <a:pPr/>
             <a:r>
-              <a:t>ml_enzyme_opt</a:t>
+              <a:t>0002+0003 ML/DE</a:t>
             </a:r>
           </a:p>
         </p:txBody>
@@ -7261,7 +7261,7 @@
           <a:p xmlns:a="http://schemas.openxmlformats.org/drawingml/2006/main">
             <a:pPr/>
             <a:r>
-              <a:t>ML 设计 + 活性优化</a:t>
+              <a:t>文库设计 + 进化复盘</a:t>
             </a:r>
           </a:p>
         </p:txBody>
@@ -7395,7 +7395,7 @@
           <a:p xmlns:a="http://schemas.openxmlformats.org/drawingml/2006/main">
             <a:pPr/>
             <a:r>
-              <a:t>模型输入、实验结果</a:t>
+              <a:t>模型输入、结构证据</a:t>
             </a:r>
           </a:p>
         </p:txBody>
@@ -7462,7 +7462,7 @@
           <a:p xmlns:a="http://schemas.openxmlformats.org/drawingml/2006/main">
             <a:pPr/>
             <a:r>
-              <a:t>biocatalysis_case</a:t>
+              <a:t>0004 Pro-PRIME</a:t>
             </a:r>
           </a:p>
         </p:txBody>
@@ -7529,7 +7529,7 @@
           <a:p xmlns:a="http://schemas.openxmlformats.org/drawingml/2006/main">
             <a:pPr/>
             <a:r>
-              <a:t>生物催化</a:t>
+              <a:t>工业抗体</a:t>
             </a:r>
           </a:p>
         </p:txBody>
@@ -7596,7 +7596,7 @@
           <a:p xmlns:a="http://schemas.openxmlformats.org/drawingml/2006/main">
             <a:pPr/>
             <a:r>
-              <a:t>定向进化 + 验证</a:t>
+              <a:t>LLM + 生产验证</a:t>
             </a:r>
           </a:p>
         </p:txBody>
@@ -7730,7 +7730,7 @@
           <a:p xmlns:a="http://schemas.openxmlformats.org/drawingml/2006/main">
             <a:pPr/>
             <a:r>
-              <a:t>轮次指标、终点结论</a:t>
+              <a:t>65 突变、DBC、epistasis</a:t>
             </a:r>
           </a:p>
         </p:txBody>
@@ -7797,7 +7797,7 @@
           <a:p xmlns:a="http://schemas.openxmlformats.org/drawingml/2006/main">
             <a:pPr/>
             <a:r>
-              <a:t>openalex_queue</a:t>
+              <a:t>0005 signal leader</a:t>
             </a:r>
           </a:p>
         </p:txBody>
@@ -7864,7 +7864,7 @@
           <a:p xmlns:a="http://schemas.openxmlformats.org/drawingml/2006/main">
             <a:pPr/>
             <a:r>
-              <a:t>候选扩展</a:t>
+              <a:t>酵母分泌</a:t>
             </a:r>
           </a:p>
         </p:txBody>
@@ -7931,7 +7931,7 @@
           <a:p xmlns:a="http://schemas.openxmlformats.org/drawingml/2006/main">
             <a:pPr/>
             <a:r>
-              <a:t>许可筛选 + 后续解析</a:t>
+              <a:t>bottom-up + top-down</a:t>
             </a:r>
           </a:p>
         </p:txBody>
@@ -7998,7 +7998,7 @@
           <a:p xmlns:a="http://schemas.openxmlformats.org/drawingml/2006/main">
             <a:pPr/>
             <a:r>
-              <a:t>14 可处理</a:t>
+              <a:t>CC-BY</a:t>
             </a:r>
           </a:p>
         </p:txBody>
@@ -8065,7 +8065,7 @@
           <a:p xmlns:a="http://schemas.openxmlformats.org/drawingml/2006/main">
             <a:pPr/>
             <a:r>
-              <a:t>DOI、OA 链接、许可状态</a:t>
+              <a:t>1600 克隆、跨酶验证</a:t>
             </a:r>
           </a:p>
         </p:txBody>
@@ -10403,7 +10403,7 @@
           <a:p xmlns:a="http://schemas.openxmlformats.org/drawingml/2006/main">
             <a:pPr/>
             <a:r>
-              <a:t>3/3</a:t>
+              <a:t>5/5</a:t>
             </a:r>
           </a:p>
         </p:txBody>
@@ -10505,7 +10505,7 @@
           <a:p xmlns:a="http://schemas.openxmlformats.org/drawingml/2006/main">
             <a:pPr/>
             <a:r>
-              <a:t>37</a:t>
+              <a:t>63</a:t>
             </a:r>
           </a:p>
         </p:txBody>
@@ -10846,7 +10846,7 @@
           <a:p xmlns:a="http://schemas.openxmlformats.org/drawingml/2006/main">
             <a:pPr/>
             <a:r>
-              <a:t>CC-BY 2 / 样例待复核 1</a:t>
+              <a:t>CC-BY 4 / 样例待复核 1</a:t>
             </a:r>
           </a:p>
         </p:txBody>
@@ -11906,7 +11906,7 @@
           <p:nvPr/>
         </p:nvPicPr>
         <p:blipFill>
-          <a:blip r:embed="rId4"/>
+          <a:blip r:embed="rId5"/>
           <a:stretch>
             <a:fillRect/>
           </a:stretch>

</xml_diff>